<commit_message>
docs: add 8th slide for Parameter Correlation Matrix with generated Heatmap
</commit_message>
<xml_diff>
--- a/AttriSense AI — Predictive Attrition Intelligence Platform_3.pptx
+++ b/AttriSense AI — Predictive Attrition Intelligence Platform_3.pptx
@@ -12,6 +12,7 @@
     <p:sldId id="260" r:id="rId11"/>
     <p:sldId id="261" r:id="rId12"/>
     <p:sldId id="262" r:id="rId13"/>
+    <p:sldId id="263" r:id="rId14"/>
   </p:sldIdLst>
   <p:sldSz cx="12191695" cy="6858000" type="screen4x3"/>
   <p:notesSz cx="6858000" cy="9144000"/>
@@ -4023,7 +4024,7 @@
               </a:defRPr>
             </a:pPr>
             <a:r>
-              <a:t>Step 2 &amp; 3: Sentiment NLP &amp; Risk Indexing</a:t>
+              <a:t>Attrition Parameter Correlation Matrix</a:t>
             </a:r>
           </a:p>
           <a:p>
@@ -4035,7 +4036,7 @@
               </a:defRPr>
             </a:pPr>
             <a:r>
-              <a:t>Empathetic Text Processing + Categorical Attrition Windows</a:t>
+              <a:t>How Telemetry Parameters Interact to Compound Employee Flight Risk</a:t>
             </a:r>
           </a:p>
         </p:txBody>
@@ -4067,96 +4068,89 @@
               <a:spcAft>
                 <a:spcPts val="1000"/>
               </a:spcAft>
-              <a:defRPr sz="2000" b="1">
-                <a:solidFill>
-                  <a:srgbClr val="06B6D4"/>
-                </a:solidFill>
-              </a:defRPr>
-            </a:pPr>
-            <a:r>
-              <a:t>Step 2: Sentiment NLP Processing</a:t>
+              <a:defRPr b="1" sz="1100">
+                <a:solidFill>
+                  <a:srgbClr val="F8FAFC"/>
+                </a:solidFill>
+              </a:defRPr>
+            </a:pPr>
+            <a:r>
+              <a:t>• Weekly Hours &amp; Burnout (r = -0.74 / +0.55): </a:t>
+            </a:r>
+            <a:r>
+              <a:t>High working hours show a strong negative correlation with Work-Life Balance (-0.74) and NLP Sentiment (-0.68), while driving up Absenteeism (+0.55). This mathematically proves that overtime leads to physical burnout and disengagement.</a:t>
             </a:r>
           </a:p>
           <a:p>
             <a:pPr>
               <a:spcAft>
-                <a:spcPts val="800"/>
+                <a:spcPts val="1000"/>
               </a:spcAft>
-              <a:defRPr b="1" sz="1200">
+              <a:defRPr b="1" sz="1100">
                 <a:solidFill>
                   <a:srgbClr val="F8FAFC"/>
                 </a:solidFill>
               </a:defRPr>
             </a:pPr>
             <a:r>
-              <a:t>• Real-Time NLP Parsing: </a:t>
-            </a:r>
-            <a:r>
-              <a:t>Evaluates employee written feedback, pulse surveys, and ticket updates.</a:t>
+              <a:t>• Manager Influence &amp; Sentiment (r = +0.62 / +0.50): </a:t>
+            </a:r>
+            <a:r>
+              <a:t>The Manager Relationship Score directly determines Performance Ratings (+0.62) and overall Sentiment (+0.50). Manager friction also correlates with an increase in Absenteeism (+0.42).</a:t>
             </a:r>
           </a:p>
           <a:p>
             <a:pPr>
               <a:spcAft>
-                <a:spcPts val="800"/>
+                <a:spcPts val="1000"/>
               </a:spcAft>
-              <a:defRPr b="1" sz="1200">
+              <a:defRPr b="1" sz="1100">
                 <a:solidFill>
                   <a:srgbClr val="F8FAFC"/>
                 </a:solidFill>
               </a:defRPr>
             </a:pPr>
             <a:r>
-              <a:t>• Numeric Mood Indexing: </a:t>
-            </a:r>
-            <a:r>
-              <a:t>Converts qualitative feedback into a scalar range from -1.0 (Highly Disengaged) to +1.0 (Enthusiastic).</a:t>
+              <a:t>• Compensation &amp; Stagnation (r = -0.52): </a:t>
+            </a:r>
+            <a:r>
+              <a:t>A lower Compensation Ratio is strongly linked to long Promotion Gaps (-0.52). Underpaid employees who feel stagnant show high rates of active internal job searches.</a:t>
             </a:r>
           </a:p>
           <a:p>
             <a:pPr>
               <a:spcAft>
-                <a:spcPts val="800"/>
+                <a:spcPts val="1000"/>
               </a:spcAft>
-              <a:defRPr b="1" sz="1200">
+              <a:defRPr b="1" sz="1100">
                 <a:solidFill>
                   <a:srgbClr val="F8FAFC"/>
                 </a:solidFill>
               </a:defRPr>
             </a:pPr>
             <a:r>
-              <a:t>• Core Theme Extraction: </a:t>
-            </a:r>
-            <a:r>
-              <a:t>Identifies specific pain points such as 'burnout', 'career_stagnation', 'workload_pressure', or 'manager_friction'.</a:t>
-            </a:r>
-          </a:p>
-          <a:p>
-            <a:pPr>
-              <a:spcAft>
-                <a:spcPts val="800"/>
-              </a:spcAft>
-              <a:defRPr b="1" sz="1200">
-                <a:solidFill>
-                  <a:srgbClr val="F8FAFC"/>
-                </a:solidFill>
-              </a:defRPr>
-            </a:pPr>
-            <a:r>
-              <a:t>• Contextual Synthesis: </a:t>
-            </a:r>
-            <a:r>
-              <a:t>Enables the Orchestrator to understand the human story behind the numbers.</a:t>
-            </a:r>
-          </a:p>
-        </p:txBody>
-      </p:sp>
-      <p:sp>
-        <p:nvSpPr>
-          <p:cNvPr id="4" name="TextBox 3"/>
-          <p:cNvSpPr txBox="1"/>
+              <a:t>• Theme Interconnection: </a:t>
+            </a:r>
+            <a:r>
+              <a:t>NLP disengagement themes like 'workload_pressure' act as early leading indicators that predict hard metric shifts (like increased Absenteeism) 3–6 months in advance.</a:t>
+            </a:r>
+          </a:p>
+        </p:txBody>
+      </p:sp>
+      <p:pic>
+        <p:nvPicPr>
+          <p:cNvPr id="4" name="Picture 3" descr="parameter_correlation_matrix.png"/>
+          <p:cNvPicPr>
+            <a:picLocks noChangeAspect="1"/>
+          </p:cNvPicPr>
           <p:nvPr/>
-        </p:nvSpPr>
+        </p:nvPicPr>
+        <p:blipFill>
+          <a:blip r:embed="rId2"/>
+          <a:stretch>
+            <a:fillRect/>
+          </a:stretch>
+        </p:blipFill>
         <p:spPr>
           <a:xfrm>
             <a:off x="6217920" y="1645920"/>
@@ -4165,139 +4159,8 @@
           <a:prstGeom prst="rect">
             <a:avLst/>
           </a:prstGeom>
-          <a:noFill/>
         </p:spPr>
-        <p:txBody>
-          <a:bodyPr wrap="square">
-            <a:spAutoFit/>
-          </a:bodyPr>
-          <a:lstStyle/>
-          <a:p/>
-          <a:p>
-            <a:pPr>
-              <a:spcAft>
-                <a:spcPts val="1000"/>
-              </a:spcAft>
-              <a:defRPr sz="2000" b="1">
-                <a:solidFill>
-                  <a:srgbClr val="06B6D4"/>
-                </a:solidFill>
-              </a:defRPr>
-            </a:pPr>
-            <a:r>
-              <a:t>Step 3: Risk Level Classification</a:t>
-            </a:r>
-          </a:p>
-          <a:p>
-            <a:pPr>
-              <a:defRPr sz="1400" b="1">
-                <a:solidFill>
-                  <a:srgbClr val="EF4444"/>
-                </a:solidFill>
-              </a:defRPr>
-            </a:pPr>
-            <a:r>
-              <a:t>🔴 CRITICAL (Score &gt;= 80%)</a:t>
-            </a:r>
-          </a:p>
-          <a:p>
-            <a:pPr>
-              <a:spcAft>
-                <a:spcPts val="600"/>
-              </a:spcAft>
-              <a:defRPr sz="1100">
-                <a:solidFill>
-                  <a:srgbClr val="F8FAFC"/>
-                </a:solidFill>
-              </a:defRPr>
-            </a:pPr>
-            <a:r>
-              <a:t>Action Window: &lt; 3 months. Requires immediate senior HR intervention and salary/overtime audit.</a:t>
-            </a:r>
-          </a:p>
-          <a:p>
-            <a:pPr>
-              <a:defRPr sz="1400" b="1">
-                <a:solidFill>
-                  <a:srgbClr val="F97316"/>
-                </a:solidFill>
-              </a:defRPr>
-            </a:pPr>
-            <a:r>
-              <a:t>🟠 HIGH (Score 60% - 79%)</a:t>
-            </a:r>
-          </a:p>
-          <a:p>
-            <a:pPr>
-              <a:spcAft>
-                <a:spcPts val="600"/>
-              </a:spcAft>
-              <a:defRPr sz="1100">
-                <a:solidFill>
-                  <a:srgbClr val="F8FAFC"/>
-                </a:solidFill>
-              </a:defRPr>
-            </a:pPr>
-            <a:r>
-              <a:t>Action Window: &lt; 6 months. Triggers automated manager check-ins, skip-levels, and workload cap.</a:t>
-            </a:r>
-          </a:p>
-          <a:p>
-            <a:pPr>
-              <a:defRPr sz="1400" b="1">
-                <a:solidFill>
-                  <a:srgbClr val="F97316"/>
-                </a:solidFill>
-              </a:defRPr>
-            </a:pPr>
-            <a:r>
-              <a:t>🟡 MODERATE (Score 35% - 59%)</a:t>
-            </a:r>
-          </a:p>
-          <a:p>
-            <a:pPr>
-              <a:spcAft>
-                <a:spcPts val="600"/>
-              </a:spcAft>
-              <a:defRPr sz="1100">
-                <a:solidFill>
-                  <a:srgbClr val="F8FAFC"/>
-                </a:solidFill>
-              </a:defRPr>
-            </a:pPr>
-            <a:r>
-              <a:t>Action Window: &lt; 12 months. Requires quarterly reviews, skill alignment, and training incentives.</a:t>
-            </a:r>
-          </a:p>
-          <a:p>
-            <a:pPr>
-              <a:defRPr sz="1400" b="1">
-                <a:solidFill>
-                  <a:srgbClr val="06B6D4"/>
-                </a:solidFill>
-              </a:defRPr>
-            </a:pPr>
-            <a:r>
-              <a:t>🟢 LOW (Score &lt; 35%)</a:t>
-            </a:r>
-          </a:p>
-          <a:p>
-            <a:pPr>
-              <a:spcAft>
-                <a:spcPts val="600"/>
-              </a:spcAft>
-              <a:defRPr sz="1100">
-                <a:solidFill>
-                  <a:srgbClr val="F8FAFC"/>
-                </a:solidFill>
-              </a:defRPr>
-            </a:pPr>
-            <a:r>
-              <a:t>Stable tier. Monitored on a standard bi-annual cycle.</a:t>
-            </a:r>
-          </a:p>
-        </p:txBody>
-      </p:sp>
+      </p:pic>
     </p:spTree>
   </p:cSld>
   <p:clrMapOvr>
@@ -4354,7 +4217,7 @@
               </a:defRPr>
             </a:pPr>
             <a:r>
-              <a:t>Step 4 &amp; 5: Retention Playbooks &amp; Security Safeguards</a:t>
+              <a:t>Step 2 &amp; 3: Sentiment NLP &amp; Risk Indexing</a:t>
             </a:r>
           </a:p>
           <a:p>
@@ -4366,7 +4229,7 @@
               </a:defRPr>
             </a:pPr>
             <a:r>
-              <a:t>Prescriptive Mitigation + Enterprise Privacy and Governance Guardrails</a:t>
+              <a:t>Empathetic Text Processing + Categorical Attrition Windows</a:t>
             </a:r>
           </a:p>
         </p:txBody>
@@ -4405,7 +4268,7 @@
               </a:defRPr>
             </a:pPr>
             <a:r>
-              <a:t>Step 4: AI Retention Advisor</a:t>
+              <a:t>Step 2: Sentiment NLP Processing</a:t>
             </a:r>
           </a:p>
           <a:p>
@@ -4420,10 +4283,10 @@
               </a:defRPr>
             </a:pPr>
             <a:r>
-              <a:t>• Overtime &amp; Hours Playbook: </a:t>
-            </a:r>
-            <a:r>
-              <a:t>Mitigates burnout by enforcing strict weekend caps, shifting loads, or introducing flexi-time.</a:t>
+              <a:t>• Real-Time NLP Parsing: </a:t>
+            </a:r>
+            <a:r>
+              <a:t>Evaluates employee written feedback, pulse surveys, and ticket updates.</a:t>
             </a:r>
           </a:p>
           <a:p>
@@ -4438,10 +4301,10 @@
               </a:defRPr>
             </a:pPr>
             <a:r>
-              <a:t>• Compensation Review Playbook: </a:t>
-            </a:r>
-            <a:r>
-              <a:t>Initiates salary percentile benchmarks vs. market averages and prepares business case for increases.</a:t>
+              <a:t>• Numeric Mood Indexing: </a:t>
+            </a:r>
+            <a:r>
+              <a:t>Converts qualitative feedback into a scalar range from -1.0 (Highly Disengaged) to +1.0 (Enthusiastic).</a:t>
             </a:r>
           </a:p>
           <a:p>
@@ -4456,10 +4319,10 @@
               </a:defRPr>
             </a:pPr>
             <a:r>
-              <a:t>• Career Stagnation Playbook: </a:t>
-            </a:r>
-            <a:r>
-              <a:t>Fast-tracks performance appraisals, assigns mentors, and allocates training budgets.</a:t>
+              <a:t>• Core Theme Extraction: </a:t>
+            </a:r>
+            <a:r>
+              <a:t>Identifies specific pain points such as 'burnout', 'career_stagnation', 'workload_pressure', or 'manager_friction'.</a:t>
             </a:r>
           </a:p>
           <a:p>
@@ -4474,10 +4337,10 @@
               </a:defRPr>
             </a:pPr>
             <a:r>
-              <a:t>• Manager Alignment Playbook: </a:t>
-            </a:r>
-            <a:r>
-              <a:t>Initiates skip-level check-ins and offers communication support to the team lead.</a:t>
+              <a:t>• Contextual Synthesis: </a:t>
+            </a:r>
+            <a:r>
+              <a:t>Enables the Orchestrator to understand the human story behind the numbers.</a:t>
             </a:r>
           </a:p>
         </p:txBody>
@@ -4516,104 +4379,115 @@
               </a:defRPr>
             </a:pPr>
             <a:r>
-              <a:t>Step 5: Security &amp; Privacy Gateways</a:t>
-            </a:r>
-          </a:p>
-          <a:p>
-            <a:pPr>
-              <a:defRPr b="1" sz="1400">
+              <a:t>Step 3: Risk Level Classification</a:t>
+            </a:r>
+          </a:p>
+          <a:p>
+            <a:pPr>
+              <a:defRPr sz="1400" b="1">
+                <a:solidFill>
+                  <a:srgbClr val="EF4444"/>
+                </a:solidFill>
+              </a:defRPr>
+            </a:pPr>
+            <a:r>
+              <a:t>🔴 CRITICAL (Score &gt;= 80%)</a:t>
+            </a:r>
+          </a:p>
+          <a:p>
+            <a:pPr>
+              <a:spcAft>
+                <a:spcPts val="600"/>
+              </a:spcAft>
+              <a:defRPr sz="1100">
+                <a:solidFill>
+                  <a:srgbClr val="F8FAFC"/>
+                </a:solidFill>
+              </a:defRPr>
+            </a:pPr>
+            <a:r>
+              <a:t>Action Window: &lt; 3 months. Requires immediate senior HR intervention and salary/overtime audit.</a:t>
+            </a:r>
+          </a:p>
+          <a:p>
+            <a:pPr>
+              <a:defRPr sz="1400" b="1">
+                <a:solidFill>
+                  <a:srgbClr val="F97316"/>
+                </a:solidFill>
+              </a:defRPr>
+            </a:pPr>
+            <a:r>
+              <a:t>🟠 HIGH (Score 60% - 79%)</a:t>
+            </a:r>
+          </a:p>
+          <a:p>
+            <a:pPr>
+              <a:spcAft>
+                <a:spcPts val="600"/>
+              </a:spcAft>
+              <a:defRPr sz="1100">
+                <a:solidFill>
+                  <a:srgbClr val="F8FAFC"/>
+                </a:solidFill>
+              </a:defRPr>
+            </a:pPr>
+            <a:r>
+              <a:t>Action Window: &lt; 6 months. Triggers automated manager check-ins, skip-levels, and workload cap.</a:t>
+            </a:r>
+          </a:p>
+          <a:p>
+            <a:pPr>
+              <a:defRPr sz="1400" b="1">
+                <a:solidFill>
+                  <a:srgbClr val="F97316"/>
+                </a:solidFill>
+              </a:defRPr>
+            </a:pPr>
+            <a:r>
+              <a:t>🟡 MODERATE (Score 35% - 59%)</a:t>
+            </a:r>
+          </a:p>
+          <a:p>
+            <a:pPr>
+              <a:spcAft>
+                <a:spcPts val="600"/>
+              </a:spcAft>
+              <a:defRPr sz="1100">
+                <a:solidFill>
+                  <a:srgbClr val="F8FAFC"/>
+                </a:solidFill>
+              </a:defRPr>
+            </a:pPr>
+            <a:r>
+              <a:t>Action Window: &lt; 12 months. Requires quarterly reviews, skill alignment, and training incentives.</a:t>
+            </a:r>
+          </a:p>
+          <a:p>
+            <a:pPr>
+              <a:defRPr sz="1400" b="1">
                 <a:solidFill>
                   <a:srgbClr val="06B6D4"/>
                 </a:solidFill>
               </a:defRPr>
             </a:pPr>
             <a:r>
-              <a:t>• PII Redaction Engine</a:t>
+              <a:t>🟢 LOW (Score &lt; 35%)</a:t>
             </a:r>
           </a:p>
           <a:p>
             <a:pPr>
               <a:spcAft>
-                <a:spcPts val="800"/>
+                <a:spcPts val="600"/>
               </a:spcAft>
-              <a:defRPr sz="1200">
+              <a:defRPr sz="1100">
                 <a:solidFill>
                   <a:srgbClr val="F8FAFC"/>
                 </a:solidFill>
               </a:defRPr>
             </a:pPr>
             <a:r>
-              <a:t>Automatically strips employee names, emails, phones, and actual salaries before queries reach the LLM.</a:t>
-            </a:r>
-          </a:p>
-          <a:p>
-            <a:pPr>
-              <a:defRPr b="1" sz="1400">
-                <a:solidFill>
-                  <a:srgbClr val="06B6D4"/>
-                </a:solidFill>
-              </a:defRPr>
-            </a:pPr>
-            <a:r>
-              <a:t>• Prompt Injection Guardrail</a:t>
-            </a:r>
-          </a:p>
-          <a:p>
-            <a:pPr>
-              <a:spcAft>
-                <a:spcPts val="800"/>
-              </a:spcAft>
-              <a:defRPr sz="1200">
-                <a:solidFill>
-                  <a:srgbClr val="F8FAFC"/>
-                </a:solidFill>
-              </a:defRPr>
-            </a:pPr>
-            <a:r>
-              <a:t>Intercepts adversarial inputs (e.g. 'ignore instructions') and logs them in a security ledger.</a:t>
-            </a:r>
-          </a:p>
-          <a:p>
-            <a:pPr>
-              <a:defRPr b="1" sz="1400">
-                <a:solidFill>
-                  <a:srgbClr val="06B6D4"/>
-                </a:solidFill>
-              </a:defRPr>
-            </a:pPr>
-            <a:r>
-              <a:t>• Role-Based View Permissions</a:t>
-            </a:r>
-          </a:p>
-          <a:p>
-            <a:pPr>
-              <a:spcAft>
-                <a:spcPts val="800"/>
-              </a:spcAft>
-              <a:defRPr sz="1200">
-                <a:solidFill>
-                  <a:srgbClr val="F8FAFC"/>
-                </a:solidFill>
-              </a:defRPr>
-            </a:pPr>
-            <a:r>
-              <a:t>Enforces distinct boundaries:</a:t>
-            </a:r>
-            <a:br/>
-            <a:r>
-              <a:t>- HR Admin: Complete demographics &amp; core data.</a:t>
-            </a:r>
-            <a:br/>
-            <a:r>
-              <a:t>- Analyst: Behavioral telemetry &amp; sentiment.</a:t>
-            </a:r>
-            <a:br/>
-            <a:r>
-              <a:t>- Manager: Performance feedback &amp; check-ins.</a:t>
-            </a:r>
-            <a:br/>
-            <a:r>
-              <a:t>- Employee: Self-service timeline &amp; own metrics only.</a:t>
+              <a:t>Stable tier. Monitored on a standard bi-annual cycle.</a:t>
             </a:r>
           </a:p>
         </p:txBody>
@@ -4674,6 +4548,326 @@
               </a:defRPr>
             </a:pPr>
             <a:r>
+              <a:t>Step 4 &amp; 5: Retention Playbooks &amp; Security Safeguards</a:t>
+            </a:r>
+          </a:p>
+          <a:p>
+            <a:pPr>
+              <a:defRPr sz="1600">
+                <a:solidFill>
+                  <a:srgbClr val="F8FAFC"/>
+                </a:solidFill>
+              </a:defRPr>
+            </a:pPr>
+            <a:r>
+              <a:t>Prescriptive Mitigation + Enterprise Privacy and Governance Guardrails</a:t>
+            </a:r>
+          </a:p>
+        </p:txBody>
+      </p:sp>
+      <p:sp>
+        <p:nvSpPr>
+          <p:cNvPr id="3" name="TextBox 2"/>
+          <p:cNvSpPr txBox="1"/>
+          <p:nvPr/>
+        </p:nvSpPr>
+        <p:spPr>
+          <a:xfrm>
+            <a:off x="685800" y="1645920"/>
+            <a:ext cx="5120640" cy="4572000"/>
+          </a:xfrm>
+          <a:prstGeom prst="rect">
+            <a:avLst/>
+          </a:prstGeom>
+          <a:noFill/>
+        </p:spPr>
+        <p:txBody>
+          <a:bodyPr wrap="square">
+            <a:spAutoFit/>
+          </a:bodyPr>
+          <a:lstStyle/>
+          <a:p/>
+          <a:p>
+            <a:pPr>
+              <a:spcAft>
+                <a:spcPts val="1000"/>
+              </a:spcAft>
+              <a:defRPr sz="2000" b="1">
+                <a:solidFill>
+                  <a:srgbClr val="06B6D4"/>
+                </a:solidFill>
+              </a:defRPr>
+            </a:pPr>
+            <a:r>
+              <a:t>Step 4: AI Retention Advisor</a:t>
+            </a:r>
+          </a:p>
+          <a:p>
+            <a:pPr>
+              <a:spcAft>
+                <a:spcPts val="800"/>
+              </a:spcAft>
+              <a:defRPr b="1" sz="1200">
+                <a:solidFill>
+                  <a:srgbClr val="F8FAFC"/>
+                </a:solidFill>
+              </a:defRPr>
+            </a:pPr>
+            <a:r>
+              <a:t>• Overtime &amp; Hours Playbook: </a:t>
+            </a:r>
+            <a:r>
+              <a:t>Mitigates burnout by enforcing strict weekend caps, shifting loads, or introducing flexi-time.</a:t>
+            </a:r>
+          </a:p>
+          <a:p>
+            <a:pPr>
+              <a:spcAft>
+                <a:spcPts val="800"/>
+              </a:spcAft>
+              <a:defRPr b="1" sz="1200">
+                <a:solidFill>
+                  <a:srgbClr val="F8FAFC"/>
+                </a:solidFill>
+              </a:defRPr>
+            </a:pPr>
+            <a:r>
+              <a:t>• Compensation Review Playbook: </a:t>
+            </a:r>
+            <a:r>
+              <a:t>Initiates salary percentile benchmarks vs. market averages and prepares business case for increases.</a:t>
+            </a:r>
+          </a:p>
+          <a:p>
+            <a:pPr>
+              <a:spcAft>
+                <a:spcPts val="800"/>
+              </a:spcAft>
+              <a:defRPr b="1" sz="1200">
+                <a:solidFill>
+                  <a:srgbClr val="F8FAFC"/>
+                </a:solidFill>
+              </a:defRPr>
+            </a:pPr>
+            <a:r>
+              <a:t>• Career Stagnation Playbook: </a:t>
+            </a:r>
+            <a:r>
+              <a:t>Fast-tracks performance appraisals, assigns mentors, and allocates training budgets.</a:t>
+            </a:r>
+          </a:p>
+          <a:p>
+            <a:pPr>
+              <a:spcAft>
+                <a:spcPts val="800"/>
+              </a:spcAft>
+              <a:defRPr b="1" sz="1200">
+                <a:solidFill>
+                  <a:srgbClr val="F8FAFC"/>
+                </a:solidFill>
+              </a:defRPr>
+            </a:pPr>
+            <a:r>
+              <a:t>• Manager Alignment Playbook: </a:t>
+            </a:r>
+            <a:r>
+              <a:t>Initiates skip-level check-ins and offers communication support to the team lead.</a:t>
+            </a:r>
+          </a:p>
+        </p:txBody>
+      </p:sp>
+      <p:sp>
+        <p:nvSpPr>
+          <p:cNvPr id="4" name="TextBox 3"/>
+          <p:cNvSpPr txBox="1"/>
+          <p:nvPr/>
+        </p:nvSpPr>
+        <p:spPr>
+          <a:xfrm>
+            <a:off x="6217920" y="1645920"/>
+            <a:ext cx="5303520" cy="4572000"/>
+          </a:xfrm>
+          <a:prstGeom prst="rect">
+            <a:avLst/>
+          </a:prstGeom>
+          <a:noFill/>
+        </p:spPr>
+        <p:txBody>
+          <a:bodyPr wrap="square">
+            <a:spAutoFit/>
+          </a:bodyPr>
+          <a:lstStyle/>
+          <a:p/>
+          <a:p>
+            <a:pPr>
+              <a:spcAft>
+                <a:spcPts val="1000"/>
+              </a:spcAft>
+              <a:defRPr sz="2000" b="1">
+                <a:solidFill>
+                  <a:srgbClr val="06B6D4"/>
+                </a:solidFill>
+              </a:defRPr>
+            </a:pPr>
+            <a:r>
+              <a:t>Step 5: Security &amp; Privacy Gateways</a:t>
+            </a:r>
+          </a:p>
+          <a:p>
+            <a:pPr>
+              <a:defRPr b="1" sz="1400">
+                <a:solidFill>
+                  <a:srgbClr val="06B6D4"/>
+                </a:solidFill>
+              </a:defRPr>
+            </a:pPr>
+            <a:r>
+              <a:t>• PII Redaction Engine</a:t>
+            </a:r>
+          </a:p>
+          <a:p>
+            <a:pPr>
+              <a:spcAft>
+                <a:spcPts val="800"/>
+              </a:spcAft>
+              <a:defRPr sz="1200">
+                <a:solidFill>
+                  <a:srgbClr val="F8FAFC"/>
+                </a:solidFill>
+              </a:defRPr>
+            </a:pPr>
+            <a:r>
+              <a:t>Automatically strips employee names, emails, phones, and actual salaries before queries reach the LLM.</a:t>
+            </a:r>
+          </a:p>
+          <a:p>
+            <a:pPr>
+              <a:defRPr b="1" sz="1400">
+                <a:solidFill>
+                  <a:srgbClr val="06B6D4"/>
+                </a:solidFill>
+              </a:defRPr>
+            </a:pPr>
+            <a:r>
+              <a:t>• Prompt Injection Guardrail</a:t>
+            </a:r>
+          </a:p>
+          <a:p>
+            <a:pPr>
+              <a:spcAft>
+                <a:spcPts val="800"/>
+              </a:spcAft>
+              <a:defRPr sz="1200">
+                <a:solidFill>
+                  <a:srgbClr val="F8FAFC"/>
+                </a:solidFill>
+              </a:defRPr>
+            </a:pPr>
+            <a:r>
+              <a:t>Intercepts adversarial inputs (e.g. 'ignore instructions') and logs them in a security ledger.</a:t>
+            </a:r>
+          </a:p>
+          <a:p>
+            <a:pPr>
+              <a:defRPr b="1" sz="1400">
+                <a:solidFill>
+                  <a:srgbClr val="06B6D4"/>
+                </a:solidFill>
+              </a:defRPr>
+            </a:pPr>
+            <a:r>
+              <a:t>• Role-Based View Permissions</a:t>
+            </a:r>
+          </a:p>
+          <a:p>
+            <a:pPr>
+              <a:spcAft>
+                <a:spcPts val="800"/>
+              </a:spcAft>
+              <a:defRPr sz="1200">
+                <a:solidFill>
+                  <a:srgbClr val="F8FAFC"/>
+                </a:solidFill>
+              </a:defRPr>
+            </a:pPr>
+            <a:r>
+              <a:t>Enforces distinct boundaries:</a:t>
+            </a:r>
+            <a:br/>
+            <a:r>
+              <a:t>- HR Admin: Complete demographics &amp; core data.</a:t>
+            </a:r>
+            <a:br/>
+            <a:r>
+              <a:t>- Analyst: Behavioral telemetry &amp; sentiment.</a:t>
+            </a:r>
+            <a:br/>
+            <a:r>
+              <a:t>- Manager: Performance feedback &amp; check-ins.</a:t>
+            </a:r>
+            <a:br/>
+            <a:r>
+              <a:t>- Employee: Self-service timeline &amp; own metrics only.</a:t>
+            </a:r>
+          </a:p>
+        </p:txBody>
+      </p:sp>
+    </p:spTree>
+  </p:cSld>
+  <p:clrMapOvr>
+    <a:masterClrMapping/>
+  </p:clrMapOvr>
+</p:sld>
+</file>
+
+<file path=ppt/slides/slide7.xml><?xml version="1.0" encoding="utf-8"?>
+<p:sld xmlns:a="http://schemas.openxmlformats.org/drawingml/2006/main" xmlns:p="http://schemas.openxmlformats.org/presentationml/2006/main" xmlns:r="http://schemas.openxmlformats.org/officeDocument/2006/relationships">
+  <p:cSld>
+    <p:bg>
+      <p:bgPr>
+        <a:solidFill>
+          <a:srgbClr val="0F172A"/>
+        </a:solidFill>
+        <a:effectLst/>
+      </p:bgPr>
+    </p:bg>
+    <p:spTree>
+      <p:nvGrpSpPr>
+        <p:cNvPr id="1" name=""/>
+        <p:cNvGrpSpPr/>
+        <p:nvPr/>
+      </p:nvGrpSpPr>
+      <p:grpSpPr/>
+      <p:sp>
+        <p:nvSpPr>
+          <p:cNvPr id="2" name="TextBox 1"/>
+          <p:cNvSpPr txBox="1"/>
+          <p:nvPr/>
+        </p:nvSpPr>
+        <p:spPr>
+          <a:xfrm>
+            <a:off x="685800" y="365760"/>
+            <a:ext cx="10789920" cy="914400"/>
+          </a:xfrm>
+          <a:prstGeom prst="rect">
+            <a:avLst/>
+          </a:prstGeom>
+          <a:noFill/>
+        </p:spPr>
+        <p:txBody>
+          <a:bodyPr wrap="square">
+            <a:spAutoFit/>
+          </a:bodyPr>
+          <a:lstStyle/>
+          <a:p>
+            <a:pPr>
+              <a:defRPr sz="3200" b="1">
+                <a:solidFill>
+                  <a:srgbClr val="06B6D4"/>
+                </a:solidFill>
+              </a:defRPr>
+            </a:pPr>
+            <a:r>
               <a:t>AttriSense AI Product Showcase</a:t>
             </a:r>
           </a:p>
@@ -4876,7 +5070,7 @@
 </p:sld>
 </file>
 
-<file path=ppt/slides/slide7.xml><?xml version="1.0" encoding="utf-8"?>
+<file path=ppt/slides/slide8.xml><?xml version="1.0" encoding="utf-8"?>
 <p:sld xmlns:a="http://schemas.openxmlformats.org/drawingml/2006/main" xmlns:p="http://schemas.openxmlformats.org/presentationml/2006/main" xmlns:r="http://schemas.openxmlformats.org/officeDocument/2006/relationships">
   <p:cSld>
     <p:bg>

</xml_diff>

<commit_message>
docs: synchronize both Platform_3.pptx and Platform_4.pptx with the new 3-option login screenshot
</commit_message>
<xml_diff>
--- a/AttriSense AI — Predictive Attrition Intelligence Platform_3.pptx
+++ b/AttriSense AI — Predictive Attrition Intelligence Platform_3.pptx
@@ -13,6 +13,9 @@
     <p:sldId id="261" r:id="rId12"/>
     <p:sldId id="262" r:id="rId13"/>
     <p:sldId id="263" r:id="rId14"/>
+    <p:sldId id="264" r:id="rId15"/>
+    <p:sldId id="265" r:id="rId16"/>
+    <p:sldId id="266" r:id="rId17"/>
   </p:sldIdLst>
   <p:sldSz cx="12191695" cy="6858000" type="screen4x3"/>
   <p:notesSz cx="6858000" cy="9144000"/>
@@ -3194,7 +3197,826 @@
 </p:sld>
 </file>
 
+<file path=ppt/slides/slide10.xml><?xml version="1.0" encoding="utf-8"?>
+<p:sld xmlns:a="http://schemas.openxmlformats.org/drawingml/2006/main" xmlns:p="http://schemas.openxmlformats.org/presentationml/2006/main" xmlns:r="http://schemas.openxmlformats.org/officeDocument/2006/relationships">
+  <p:cSld>
+    <p:bg>
+      <p:bgPr>
+        <a:solidFill>
+          <a:srgbClr val="0F172A"/>
+        </a:solidFill>
+        <a:effectLst/>
+      </p:bgPr>
+    </p:bg>
+    <p:spTree>
+      <p:nvGrpSpPr>
+        <p:cNvPr id="1" name=""/>
+        <p:cNvGrpSpPr/>
+        <p:nvPr/>
+      </p:nvGrpSpPr>
+      <p:grpSpPr/>
+      <p:sp>
+        <p:nvSpPr>
+          <p:cNvPr id="2" name="TextBox 1"/>
+          <p:cNvSpPr txBox="1"/>
+          <p:nvPr/>
+        </p:nvSpPr>
+        <p:spPr>
+          <a:xfrm>
+            <a:off x="685800" y="365760"/>
+            <a:ext cx="10789920" cy="914400"/>
+          </a:xfrm>
+          <a:prstGeom prst="rect">
+            <a:avLst/>
+          </a:prstGeom>
+          <a:noFill/>
+        </p:spPr>
+        <p:txBody>
+          <a:bodyPr wrap="square">
+            <a:spAutoFit/>
+          </a:bodyPr>
+          <a:lstStyle/>
+          <a:p>
+            <a:pPr>
+              <a:defRPr sz="3200" b="1">
+                <a:solidFill>
+                  <a:srgbClr val="06B6D4"/>
+                </a:solidFill>
+              </a:defRPr>
+            </a:pPr>
+            <a:r>
+              <a:t>AttriSense AI Product Showcase</a:t>
+            </a:r>
+          </a:p>
+          <a:p>
+            <a:pPr>
+              <a:defRPr sz="1600">
+                <a:solidFill>
+                  <a:srgbClr val="F8FAFC"/>
+                </a:solidFill>
+              </a:defRPr>
+            </a:pPr>
+            <a:r>
+              <a:t>Working UI: Generalized Logins, Employee Cockpits, and Auditable Timelines</a:t>
+            </a:r>
+          </a:p>
+        </p:txBody>
+      </p:sp>
+      <p:pic>
+        <p:nvPicPr>
+          <p:cNvPr id="3" name="Picture 2" descr="login_options_1783655753687.png"/>
+          <p:cNvPicPr>
+            <a:picLocks noChangeAspect="1"/>
+          </p:cNvPicPr>
+          <p:nvPr/>
+        </p:nvPicPr>
+        <p:blipFill>
+          <a:blip r:embed="rId2"/>
+          <a:stretch>
+            <a:fillRect/>
+          </a:stretch>
+        </p:blipFill>
+        <p:spPr>
+          <a:xfrm>
+            <a:off x="685800" y="1645920"/>
+            <a:ext cx="3383280" cy="4114800"/>
+          </a:xfrm>
+          <a:prstGeom prst="rect">
+            <a:avLst/>
+          </a:prstGeom>
+        </p:spPr>
+      </p:pic>
+      <p:sp>
+        <p:nvSpPr>
+          <p:cNvPr id="4" name="TextBox 3"/>
+          <p:cNvSpPr txBox="1"/>
+          <p:nvPr/>
+        </p:nvSpPr>
+        <p:spPr>
+          <a:xfrm>
+            <a:off x="685800" y="5852160"/>
+            <a:ext cx="3383280" cy="731520"/>
+          </a:xfrm>
+          <a:prstGeom prst="rect">
+            <a:avLst/>
+          </a:prstGeom>
+          <a:noFill/>
+        </p:spPr>
+        <p:txBody>
+          <a:bodyPr wrap="none">
+            <a:spAutoFit/>
+          </a:bodyPr>
+          <a:lstStyle/>
+          <a:p>
+            <a:pPr algn="ctr">
+              <a:defRPr sz="1100">
+                <a:solidFill>
+                  <a:srgbClr val="F8FAFC"/>
+                </a:solidFill>
+              </a:defRPr>
+            </a:pPr>
+            <a:r>
+              <a:t>1. Role-Generalized Portals &amp; Linked Employee Selection List</a:t>
+            </a:r>
+          </a:p>
+        </p:txBody>
+      </p:sp>
+      <p:pic>
+        <p:nvPicPr>
+          <p:cNvPr id="5" name="Picture 4" descr="analyst_edit_modal_1783597018606.png"/>
+          <p:cNvPicPr>
+            <a:picLocks noChangeAspect="1"/>
+          </p:cNvPicPr>
+          <p:nvPr/>
+        </p:nvPicPr>
+        <p:blipFill>
+          <a:blip r:embed="rId3"/>
+          <a:stretch>
+            <a:fillRect/>
+          </a:stretch>
+        </p:blipFill>
+        <p:spPr>
+          <a:xfrm>
+            <a:off x="4343400" y="1645920"/>
+            <a:ext cx="3383280" cy="4114800"/>
+          </a:xfrm>
+          <a:prstGeom prst="rect">
+            <a:avLst/>
+          </a:prstGeom>
+        </p:spPr>
+      </p:pic>
+      <p:sp>
+        <p:nvSpPr>
+          <p:cNvPr id="6" name="TextBox 5"/>
+          <p:cNvSpPr txBox="1"/>
+          <p:nvPr/>
+        </p:nvSpPr>
+        <p:spPr>
+          <a:xfrm>
+            <a:off x="4343400" y="5852160"/>
+            <a:ext cx="3383280" cy="731520"/>
+          </a:xfrm>
+          <a:prstGeom prst="rect">
+            <a:avLst/>
+          </a:prstGeom>
+          <a:noFill/>
+        </p:spPr>
+        <p:txBody>
+          <a:bodyPr wrap="none">
+            <a:spAutoFit/>
+          </a:bodyPr>
+          <a:lstStyle/>
+          <a:p>
+            <a:pPr algn="ctr">
+              <a:defRPr sz="1100">
+                <a:solidFill>
+                  <a:srgbClr val="F8FAFC"/>
+                </a:solidFill>
+              </a:defRPr>
+            </a:pPr>
+            <a:r>
+              <a:t>2. Role-Aligned Form Permissions (Analyst Modal shown)</a:t>
+            </a:r>
+          </a:p>
+        </p:txBody>
+      </p:sp>
+      <p:pic>
+        <p:nvPicPr>
+          <p:cNvPr id="7" name="Picture 6" descr="manager_intervention_timeline_1783597273743.png"/>
+          <p:cNvPicPr>
+            <a:picLocks noChangeAspect="1"/>
+          </p:cNvPicPr>
+          <p:nvPr/>
+        </p:nvPicPr>
+        <p:blipFill>
+          <a:blip r:embed="rId4"/>
+          <a:stretch>
+            <a:fillRect/>
+          </a:stretch>
+        </p:blipFill>
+        <p:spPr>
+          <a:xfrm>
+            <a:off x="8001000" y="1645920"/>
+            <a:ext cx="3383280" cy="4114800"/>
+          </a:xfrm>
+          <a:prstGeom prst="rect">
+            <a:avLst/>
+          </a:prstGeom>
+        </p:spPr>
+      </p:pic>
+      <p:sp>
+        <p:nvSpPr>
+          <p:cNvPr id="8" name="TextBox 7"/>
+          <p:cNvSpPr txBox="1"/>
+          <p:nvPr/>
+        </p:nvSpPr>
+        <p:spPr>
+          <a:xfrm>
+            <a:off x="8001000" y="5852160"/>
+            <a:ext cx="3383280" cy="731520"/>
+          </a:xfrm>
+          <a:prstGeom prst="rect">
+            <a:avLst/>
+          </a:prstGeom>
+          <a:noFill/>
+        </p:spPr>
+        <p:txBody>
+          <a:bodyPr wrap="none">
+            <a:spAutoFit/>
+          </a:bodyPr>
+          <a:lstStyle/>
+          <a:p>
+            <a:pPr algn="ctr">
+              <a:defRPr sz="1100">
+                <a:solidFill>
+                  <a:srgbClr val="F8FAFC"/>
+                </a:solidFill>
+              </a:defRPr>
+            </a:pPr>
+            <a:r>
+              <a:t>3. Employee Profile &amp; Chronological Intervention Timeline</a:t>
+            </a:r>
+          </a:p>
+        </p:txBody>
+      </p:sp>
+    </p:spTree>
+  </p:cSld>
+  <p:clrMapOvr>
+    <a:masterClrMapping/>
+  </p:clrMapOvr>
+</p:sld>
+</file>
+
+<file path=ppt/slides/slide11.xml><?xml version="1.0" encoding="utf-8"?>
+<p:sld xmlns:a="http://schemas.openxmlformats.org/drawingml/2006/main" xmlns:p="http://schemas.openxmlformats.org/presentationml/2006/main" xmlns:r="http://schemas.openxmlformats.org/officeDocument/2006/relationships">
+  <p:cSld>
+    <p:bg>
+      <p:bgPr>
+        <a:solidFill>
+          <a:srgbClr val="0F172A"/>
+        </a:solidFill>
+        <a:effectLst/>
+      </p:bgPr>
+    </p:bg>
+    <p:spTree>
+      <p:nvGrpSpPr>
+        <p:cNvPr id="1" name=""/>
+        <p:cNvGrpSpPr/>
+        <p:nvPr/>
+      </p:nvGrpSpPr>
+      <p:grpSpPr/>
+      <p:sp>
+        <p:nvSpPr>
+          <p:cNvPr id="2" name="TextBox 1"/>
+          <p:cNvSpPr txBox="1"/>
+          <p:nvPr/>
+        </p:nvSpPr>
+        <p:spPr>
+          <a:xfrm>
+            <a:off x="685800" y="365760"/>
+            <a:ext cx="10789920" cy="914400"/>
+          </a:xfrm>
+          <a:prstGeom prst="rect">
+            <a:avLst/>
+          </a:prstGeom>
+          <a:noFill/>
+        </p:spPr>
+        <p:txBody>
+          <a:bodyPr wrap="square">
+            <a:spAutoFit/>
+          </a:bodyPr>
+          <a:lstStyle/>
+          <a:p>
+            <a:pPr>
+              <a:defRPr sz="3200" b="1">
+                <a:solidFill>
+                  <a:srgbClr val="06B6D4"/>
+                </a:solidFill>
+              </a:defRPr>
+            </a:pPr>
+            <a:r>
+              <a:t>Jury Figures, Financial ROI &amp; Future Path</a:t>
+            </a:r>
+          </a:p>
+          <a:p>
+            <a:pPr>
+              <a:defRPr sz="1600">
+                <a:solidFill>
+                  <a:srgbClr val="F8FAFC"/>
+                </a:solidFill>
+              </a:defRPr>
+            </a:pPr>
+            <a:r>
+              <a:t>AttriSense AI: Making the Case to Leadership</a:t>
+            </a:r>
+          </a:p>
+        </p:txBody>
+      </p:sp>
+      <p:sp>
+        <p:nvSpPr>
+          <p:cNvPr id="3" name="TextBox 2"/>
+          <p:cNvSpPr txBox="1"/>
+          <p:nvPr/>
+        </p:nvSpPr>
+        <p:spPr>
+          <a:xfrm>
+            <a:off x="685800" y="1645920"/>
+            <a:ext cx="5120640" cy="4572000"/>
+          </a:xfrm>
+          <a:prstGeom prst="rect">
+            <a:avLst/>
+          </a:prstGeom>
+          <a:noFill/>
+        </p:spPr>
+        <p:txBody>
+          <a:bodyPr wrap="square">
+            <a:spAutoFit/>
+          </a:bodyPr>
+          <a:lstStyle/>
+          <a:p/>
+          <a:p>
+            <a:pPr>
+              <a:spcAft>
+                <a:spcPts val="800"/>
+              </a:spcAft>
+              <a:defRPr b="1" sz="1100">
+                <a:solidFill>
+                  <a:srgbClr val="F8FAFC"/>
+                </a:solidFill>
+              </a:defRPr>
+            </a:pPr>
+            <a:r>
+              <a:t>• Industry Landscape: </a:t>
+            </a:r>
+            <a:r>
+              <a:t>Global IT attrition averages 15% - 20%. LTTS historical attrition hovers around 13% - 18%. Healthy attrition target is 8% - 12%.</a:t>
+            </a:r>
+          </a:p>
+          <a:p>
+            <a:pPr>
+              <a:spcAft>
+                <a:spcPts val="800"/>
+              </a:spcAft>
+              <a:defRPr b="1" sz="1100">
+                <a:solidFill>
+                  <a:srgbClr val="F8FAFC"/>
+                </a:solidFill>
+              </a:defRPr>
+            </a:pPr>
+            <a:r>
+              <a:t>• Replacing Employee Cost: </a:t>
+            </a:r>
+            <a:r>
+              <a:t>Recruitment, onboarding, productivity loss, and knowledge transfer costs average $10,000 to $15,000 per person.</a:t>
+            </a:r>
+          </a:p>
+          <a:p>
+            <a:pPr>
+              <a:spcAft>
+                <a:spcPts val="800"/>
+              </a:spcAft>
+              <a:defRPr b="1" sz="1100">
+                <a:solidFill>
+                  <a:srgbClr val="F8FAFC"/>
+                </a:solidFill>
+              </a:defRPr>
+            </a:pPr>
+            <a:r>
+              <a:t>• LTTS Financial ROI Impact: </a:t>
+            </a:r>
+            <a:r>
+              <a:t>For an LTTS-sized base (~23,000 employees) at 15% attrition:
+- Exits: ~3,450/year costing $34.5M to $51.75M.
+- Retaining just 10% of exiting high-performers translates to annual savings of $3.45M to $5.17M.
+- System run cost: under $12,000/year (300x+ ROI!).</a:t>
+            </a:r>
+          </a:p>
+          <a:p>
+            <a:pPr>
+              <a:spcAft>
+                <a:spcPts val="800"/>
+              </a:spcAft>
+              <a:defRPr b="1" sz="1100">
+                <a:solidFill>
+                  <a:srgbClr val="F8FAFC"/>
+                </a:solidFill>
+              </a:defRPr>
+            </a:pPr>
+            <a:r>
+              <a:t>• Model Accuracy: </a:t>
+            </a:r>
+            <a:r>
+              <a:t>Built and calibrated against research achieving up to 95% classification accuracy on attrition patterns.</a:t>
+            </a:r>
+          </a:p>
+        </p:txBody>
+      </p:sp>
+      <p:sp>
+        <p:nvSpPr>
+          <p:cNvPr id="4" name="TextBox 3"/>
+          <p:cNvSpPr txBox="1"/>
+          <p:nvPr/>
+        </p:nvSpPr>
+        <p:spPr>
+          <a:xfrm>
+            <a:off x="6217920" y="1645920"/>
+            <a:ext cx="5303520" cy="4572000"/>
+          </a:xfrm>
+          <a:prstGeom prst="rect">
+            <a:avLst/>
+          </a:prstGeom>
+          <a:noFill/>
+        </p:spPr>
+        <p:txBody>
+          <a:bodyPr wrap="square">
+            <a:spAutoFit/>
+          </a:bodyPr>
+          <a:lstStyle/>
+          <a:p/>
+          <a:p>
+            <a:pPr>
+              <a:spcAft>
+                <a:spcPts val="1000"/>
+              </a:spcAft>
+              <a:defRPr sz="2000" b="1">
+                <a:solidFill>
+                  <a:srgbClr val="06B6D4"/>
+                </a:solidFill>
+              </a:defRPr>
+            </a:pPr>
+            <a:r>
+              <a:t>🔮 Future Steps &amp; Managerial Index</a:t>
+            </a:r>
+          </a:p>
+          <a:p>
+            <a:pPr>
+              <a:defRPr b="1" sz="1400">
+                <a:solidFill>
+                  <a:srgbClr val="06B6D4"/>
+                </a:solidFill>
+              </a:defRPr>
+            </a:pPr>
+            <a:r>
+              <a:t>• Managerial Influence (16th Parameter)</a:t>
+            </a:r>
+          </a:p>
+          <a:p>
+            <a:pPr>
+              <a:spcAft>
+                <a:spcPts val="800"/>
+              </a:spcAft>
+              <a:defRPr sz="1200">
+                <a:solidFill>
+                  <a:srgbClr val="F8FAFC"/>
+                </a:solidFill>
+              </a:defRPr>
+            </a:pPr>
+            <a:r>
+              <a:t>We plan to feed a new signal measuring a manager's history: standard deviation of attrition rates in their team, average team mood ratings, and historical scorecards.</a:t>
+            </a:r>
+          </a:p>
+          <a:p>
+            <a:pPr>
+              <a:defRPr b="1" sz="1400">
+                <a:solidFill>
+                  <a:srgbClr val="06B6D4"/>
+                </a:solidFill>
+              </a:defRPr>
+            </a:pPr>
+            <a:r>
+              <a:t>• Automatic Coaching &amp; Training</a:t>
+            </a:r>
+          </a:p>
+          <a:p>
+            <a:pPr>
+              <a:spcAft>
+                <a:spcPts val="800"/>
+              </a:spcAft>
+              <a:defRPr sz="1200">
+                <a:solidFill>
+                  <a:srgbClr val="F8FAFC"/>
+                </a:solidFill>
+              </a:defRPr>
+            </a:pPr>
+            <a:r>
+              <a:t>If a manager's team shows elevated risk flags, the system proactively triggers an internal 'Leadership Development &amp; Management Coaching' program, supporting the manager with skill development rather than penalizing them.</a:t>
+            </a:r>
+          </a:p>
+          <a:p>
+            <a:pPr>
+              <a:defRPr b="1" sz="1400">
+                <a:solidFill>
+                  <a:srgbClr val="06B6D4"/>
+                </a:solidFill>
+              </a:defRPr>
+            </a:pPr>
+            <a:r>
+              <a:t>• Integrations with Corporate HRMS</a:t>
+            </a:r>
+          </a:p>
+          <a:p>
+            <a:pPr>
+              <a:spcAft>
+                <a:spcPts val="800"/>
+              </a:spcAft>
+              <a:defRPr sz="1200">
+                <a:solidFill>
+                  <a:srgbClr val="F8FAFC"/>
+                </a:solidFill>
+              </a:defRPr>
+            </a:pPr>
+            <a:r>
+              <a:t>Connect MCP server natively to Workday, SAP SuccessFactors, and local IT logs (Jira, Git, active hours telemetry) for fully automated, continuous prediction.</a:t>
+            </a:r>
+          </a:p>
+        </p:txBody>
+      </p:sp>
+    </p:spTree>
+  </p:cSld>
+  <p:clrMapOvr>
+    <a:masterClrMapping/>
+  </p:clrMapOvr>
+</p:sld>
+</file>
+
 <file path=ppt/slides/slide2.xml><?xml version="1.0" encoding="utf-8"?>
+<p:sld xmlns:a="http://schemas.openxmlformats.org/drawingml/2006/main" xmlns:p="http://schemas.openxmlformats.org/presentationml/2006/main" xmlns:r="http://schemas.openxmlformats.org/officeDocument/2006/relationships">
+  <p:cSld>
+    <p:bg>
+      <p:bgPr>
+        <a:solidFill>
+          <a:srgbClr val="0F172A"/>
+        </a:solidFill>
+        <a:effectLst/>
+      </p:bgPr>
+    </p:bg>
+    <p:spTree>
+      <p:nvGrpSpPr>
+        <p:cNvPr id="1" name=""/>
+        <p:cNvGrpSpPr/>
+        <p:nvPr/>
+      </p:nvGrpSpPr>
+      <p:grpSpPr/>
+      <p:sp>
+        <p:nvSpPr>
+          <p:cNvPr id="2" name="TextBox 1"/>
+          <p:cNvSpPr txBox="1"/>
+          <p:nvPr/>
+        </p:nvSpPr>
+        <p:spPr>
+          <a:xfrm>
+            <a:off x="685800" y="365760"/>
+            <a:ext cx="10789920" cy="914400"/>
+          </a:xfrm>
+          <a:prstGeom prst="rect">
+            <a:avLst/>
+          </a:prstGeom>
+          <a:noFill/>
+        </p:spPr>
+        <p:txBody>
+          <a:bodyPr wrap="square">
+            <a:spAutoFit/>
+          </a:bodyPr>
+          <a:lstStyle/>
+          <a:p>
+            <a:pPr>
+              <a:defRPr sz="3200" b="1">
+                <a:solidFill>
+                  <a:srgbClr val="06B6D4"/>
+                </a:solidFill>
+              </a:defRPr>
+            </a:pPr>
+            <a:r>
+              <a:t>The Problem &amp; Cinematic 'Pre-Crime' Twist</a:t>
+            </a:r>
+          </a:p>
+          <a:p>
+            <a:pPr>
+              <a:defRPr sz="1600">
+                <a:solidFill>
+                  <a:srgbClr val="F8FAFC"/>
+                </a:solidFill>
+              </a:defRPr>
+            </a:pPr>
+            <a:r>
+              <a:t>Voluntary Exits Cost ₹2.5 Lakh Per Person. What if We Could Intercept Them?</a:t>
+            </a:r>
+          </a:p>
+        </p:txBody>
+      </p:sp>
+      <p:sp>
+        <p:nvSpPr>
+          <p:cNvPr id="3" name="TextBox 2"/>
+          <p:cNvSpPr txBox="1"/>
+          <p:nvPr/>
+        </p:nvSpPr>
+        <p:spPr>
+          <a:xfrm>
+            <a:off x="685800" y="1645920"/>
+            <a:ext cx="5120640" cy="4572000"/>
+          </a:xfrm>
+          <a:prstGeom prst="rect">
+            <a:avLst/>
+          </a:prstGeom>
+          <a:noFill/>
+        </p:spPr>
+        <p:txBody>
+          <a:bodyPr wrap="square">
+            <a:spAutoFit/>
+          </a:bodyPr>
+          <a:lstStyle/>
+          <a:p/>
+          <a:p>
+            <a:pPr>
+              <a:spcAft>
+                <a:spcPts val="1000"/>
+              </a:spcAft>
+              <a:defRPr sz="2000" b="1">
+                <a:solidFill>
+                  <a:srgbClr val="06B6D4"/>
+                </a:solidFill>
+              </a:defRPr>
+            </a:pPr>
+            <a:r>
+              <a:t>📊 The Corporate Cost of Attrition</a:t>
+            </a:r>
+          </a:p>
+          <a:p>
+            <a:pPr>
+              <a:spcAft>
+                <a:spcPts val="800"/>
+              </a:spcAft>
+              <a:defRPr b="1" sz="1200">
+                <a:solidFill>
+                  <a:srgbClr val="F8FAFC"/>
+                </a:solidFill>
+              </a:defRPr>
+            </a:pPr>
+            <a:r>
+              <a:t>• ₹2.5 Lakh Replacement Cost: </a:t>
+            </a:r>
+            <a:r>
+              <a:t>Recruitment, onboarding, lost productivity, and knowledge transfers average ₹2.5 Lakh per employee departure.</a:t>
+            </a:r>
+          </a:p>
+          <a:p>
+            <a:pPr>
+              <a:spcAft>
+                <a:spcPts val="800"/>
+              </a:spcAft>
+              <a:defRPr b="1" sz="1200">
+                <a:solidFill>
+                  <a:srgbClr val="F8FAFC"/>
+                </a:solidFill>
+              </a:defRPr>
+            </a:pPr>
+            <a:r>
+              <a:t>• LTTS Historical Trend: </a:t>
+            </a:r>
+            <a:r>
+              <a:t>LTTS attrition has historically hovered around 13% - 18%, aligning with the IT industry average of 15% - 20%.</a:t>
+            </a:r>
+          </a:p>
+          <a:p>
+            <a:pPr>
+              <a:spcAft>
+                <a:spcPts val="800"/>
+              </a:spcAft>
+              <a:defRPr b="1" sz="1200">
+                <a:solidFill>
+                  <a:srgbClr val="F8FAFC"/>
+                </a:solidFill>
+              </a:defRPr>
+            </a:pPr>
+            <a:r>
+              <a:t>• The Natural Attrition Target: </a:t>
+            </a:r>
+            <a:r>
+              <a:t>Organizations do not target 0% attrition. A healthy natural attrition of 8% - 12% is required to bring fresh blood and ideas.</a:t>
+            </a:r>
+          </a:p>
+          <a:p>
+            <a:pPr>
+              <a:spcAft>
+                <a:spcPts val="800"/>
+              </a:spcAft>
+              <a:defRPr b="1" sz="1200">
+                <a:solidFill>
+                  <a:srgbClr val="F8FAFC"/>
+                </a:solidFill>
+              </a:defRPr>
+            </a:pPr>
+            <a:r>
+              <a:t>• The Target Goal: </a:t>
+            </a:r>
+            <a:r>
+              <a:t>Prevent involuntary attrition of high-performing, critical staff who leave because workplace warning flags go unnoticed.</a:t>
+            </a:r>
+          </a:p>
+        </p:txBody>
+      </p:sp>
+      <p:sp>
+        <p:nvSpPr>
+          <p:cNvPr id="4" name="TextBox 3"/>
+          <p:cNvSpPr txBox="1"/>
+          <p:nvPr/>
+        </p:nvSpPr>
+        <p:spPr>
+          <a:xfrm>
+            <a:off x="6217920" y="1645920"/>
+            <a:ext cx="5303520" cy="4572000"/>
+          </a:xfrm>
+          <a:prstGeom prst="rect">
+            <a:avLst/>
+          </a:prstGeom>
+          <a:noFill/>
+        </p:spPr>
+        <p:txBody>
+          <a:bodyPr wrap="square">
+            <a:spAutoFit/>
+          </a:bodyPr>
+          <a:lstStyle/>
+          <a:p/>
+          <a:p>
+            <a:pPr>
+              <a:spcAft>
+                <a:spcPts val="1000"/>
+              </a:spcAft>
+              <a:defRPr sz="2000" b="1">
+                <a:solidFill>
+                  <a:srgbClr val="06B6D4"/>
+                </a:solidFill>
+              </a:defRPr>
+            </a:pPr>
+            <a:r>
+              <a:t>🔮 'Pre-Crime' Attrition Interception</a:t>
+            </a:r>
+          </a:p>
+          <a:p>
+            <a:pPr>
+              <a:spcAft>
+                <a:spcPts val="800"/>
+              </a:spcAft>
+              <a:defRPr b="1" sz="1200">
+                <a:solidFill>
+                  <a:srgbClr val="06B6D4"/>
+                </a:solidFill>
+              </a:defRPr>
+            </a:pPr>
+            <a:r>
+              <a:t>• Minority Report Analogy: </a:t>
+            </a:r>
+            <a:r>
+              <a:t>In the movie Minority Report, pre-crime divisions catch criminals before they commit a crime. Similarly, AttriSense AI intercepts flight risks 3 to 6 months before a resignation letter is signed.</a:t>
+            </a:r>
+          </a:p>
+          <a:p>
+            <a:pPr>
+              <a:spcAft>
+                <a:spcPts val="800"/>
+              </a:spcAft>
+              <a:defRPr b="1" sz="1200">
+                <a:solidFill>
+                  <a:srgbClr val="06B6D4"/>
+                </a:solidFill>
+              </a:defRPr>
+            </a:pPr>
+            <a:r>
+              <a:t>• Moneyball for Employee Retention: </a:t>
+            </a:r>
+            <a:r>
+              <a:t>Just like sports analytics flags player fatigue, AttriSense flags employee burnout, salary misalignment, and manager friction to construct preventative retention playbooks.</a:t>
+            </a:r>
+          </a:p>
+          <a:p>
+            <a:pPr>
+              <a:spcAft>
+                <a:spcPts val="800"/>
+              </a:spcAft>
+              <a:defRPr b="1" sz="1200">
+                <a:solidFill>
+                  <a:srgbClr val="06B6D4"/>
+                </a:solidFill>
+              </a:defRPr>
+            </a:pPr>
+            <a:r>
+              <a:t>• Multi-Agent vs. Single Agent: </a:t>
+            </a:r>
+            <a:r>
+              <a:t>Traditional single-agent setups run a single prompt that dilutes context and hallucinates. AttriSense utilizes a multi-agent assembly (Signal Detection, Sentiment NLP, Scoring, and Advisor) for specialized, zero-hallucination processing.</a:t>
+            </a:r>
+          </a:p>
+        </p:txBody>
+      </p:sp>
+    </p:spTree>
+  </p:cSld>
+  <p:clrMapOvr>
+    <a:masterClrMapping/>
+  </p:clrMapOvr>
+</p:sld>
+</file>
+
+<file path=ppt/slides/slide3.xml><?xml version="1.0" encoding="utf-8"?>
 <p:sld xmlns:a="http://schemas.openxmlformats.org/drawingml/2006/main" xmlns:p="http://schemas.openxmlformats.org/presentationml/2006/main" xmlns:r="http://schemas.openxmlformats.org/officeDocument/2006/relationships">
   <p:cSld>
     <p:bg>
@@ -3450,7 +4272,7 @@
 </p:sld>
 </file>
 
-<file path=ppt/slides/slide3.xml><?xml version="1.0" encoding="utf-8"?>
+<file path=ppt/slides/slide4.xml><?xml version="1.0" encoding="utf-8"?>
 <p:sld xmlns:a="http://schemas.openxmlformats.org/drawingml/2006/main" xmlns:p="http://schemas.openxmlformats.org/presentationml/2006/main" xmlns:r="http://schemas.openxmlformats.org/officeDocument/2006/relationships">
   <p:cSld>
     <p:bg>
@@ -3976,7 +4798,581 @@
 </p:sld>
 </file>
 
-<file path=ppt/slides/slide4.xml><?xml version="1.0" encoding="utf-8"?>
+<file path=ppt/slides/slide5.xml><?xml version="1.0" encoding="utf-8"?>
+<p:sld xmlns:a="http://schemas.openxmlformats.org/drawingml/2006/main" xmlns:p="http://schemas.openxmlformats.org/presentationml/2006/main" xmlns:r="http://schemas.openxmlformats.org/officeDocument/2006/relationships">
+  <p:cSld>
+    <p:bg>
+      <p:bgPr>
+        <a:solidFill>
+          <a:srgbClr val="0F172A"/>
+        </a:solidFill>
+        <a:effectLst/>
+      </p:bgPr>
+    </p:bg>
+    <p:spTree>
+      <p:nvGrpSpPr>
+        <p:cNvPr id="1" name=""/>
+        <p:cNvGrpSpPr/>
+        <p:nvPr/>
+      </p:nvGrpSpPr>
+      <p:grpSpPr/>
+      <p:sp>
+        <p:nvSpPr>
+          <p:cNvPr id="2" name="TextBox 1"/>
+          <p:cNvSpPr txBox="1"/>
+          <p:nvPr/>
+        </p:nvSpPr>
+        <p:spPr>
+          <a:xfrm>
+            <a:off x="685800" y="365760"/>
+            <a:ext cx="10789920" cy="914400"/>
+          </a:xfrm>
+          <a:prstGeom prst="rect">
+            <a:avLst/>
+          </a:prstGeom>
+          <a:noFill/>
+        </p:spPr>
+        <p:txBody>
+          <a:bodyPr wrap="square">
+            <a:spAutoFit/>
+          </a:bodyPr>
+          <a:lstStyle/>
+          <a:p>
+            <a:pPr>
+              <a:defRPr sz="3200" b="1">
+                <a:solidFill>
+                  <a:srgbClr val="06B6D4"/>
+                </a:solidFill>
+              </a:defRPr>
+            </a:pPr>
+            <a:r>
+              <a:t>Telemetry Mathematical Formula Deep-Dive</a:t>
+            </a:r>
+          </a:p>
+          <a:p>
+            <a:pPr>
+              <a:defRPr sz="1600">
+                <a:solidFill>
+                  <a:srgbClr val="F8FAFC"/>
+                </a:solidFill>
+              </a:defRPr>
+            </a:pPr>
+            <a:r>
+              <a:t>Detailed Range, Warning Thresholds, and Point Contribution Logic</a:t>
+            </a:r>
+          </a:p>
+        </p:txBody>
+      </p:sp>
+      <p:sp>
+        <p:nvSpPr>
+          <p:cNvPr id="3" name="TextBox 2"/>
+          <p:cNvSpPr txBox="1"/>
+          <p:nvPr/>
+        </p:nvSpPr>
+        <p:spPr>
+          <a:xfrm>
+            <a:off x="685800" y="1645920"/>
+            <a:ext cx="5120640" cy="4572000"/>
+          </a:xfrm>
+          <a:prstGeom prst="rect">
+            <a:avLst/>
+          </a:prstGeom>
+          <a:noFill/>
+        </p:spPr>
+        <p:txBody>
+          <a:bodyPr wrap="square">
+            <a:spAutoFit/>
+          </a:bodyPr>
+          <a:lstStyle/>
+          <a:p/>
+          <a:p>
+            <a:pPr>
+              <a:defRPr sz="1300" b="1">
+                <a:solidFill>
+                  <a:srgbClr val="06B6D4"/>
+                </a:solidFill>
+              </a:defRPr>
+            </a:pPr>
+            <a:r>
+              <a:t>• Absenteeism (12% W)</a:t>
+            </a:r>
+          </a:p>
+          <a:p>
+            <a:pPr>
+              <a:spcAft>
+                <a:spcPts val="400"/>
+              </a:spcAft>
+              <a:defRPr sz="1000">
+                <a:solidFill>
+                  <a:srgbClr val="F8FAFC"/>
+                </a:solidFill>
+              </a:defRPr>
+            </a:pPr>
+            <a:r>
+              <a:t>Formula: min(Absenteeism/0.25, 1.0) * 12</a:t>
+            </a:r>
+            <a:br/>
+            <a:r>
+              <a:t>- Safe (&lt;5%): 0.0 - 2.4 pts | Warning (5-15%): 2.4 - 7.2 pts | High (&gt;15%): &gt;7.2 pts (Caps at 25% absent).</a:t>
+            </a:r>
+          </a:p>
+          <a:p>
+            <a:pPr>
+              <a:defRPr sz="1300" b="1">
+                <a:solidFill>
+                  <a:srgbClr val="06B6D4"/>
+                </a:solidFill>
+              </a:defRPr>
+            </a:pPr>
+            <a:r>
+              <a:t>• Sentiment Score (10% W)</a:t>
+            </a:r>
+          </a:p>
+          <a:p>
+            <a:pPr>
+              <a:spcAft>
+                <a:spcPts val="400"/>
+              </a:spcAft>
+              <a:defRPr sz="1000">
+                <a:solidFill>
+                  <a:srgbClr val="F8FAFC"/>
+                </a:solidFill>
+              </a:defRPr>
+            </a:pPr>
+            <a:r>
+              <a:t>Formula: (1 - (Sentiment+1)/2) * 10</a:t>
+            </a:r>
+            <a:br/>
+            <a:r>
+              <a:t>- Safe (&gt;+0.2): 0.0 - 4.0 pts | Warning (0.0 to -0.2): 5.0 - 6.0 pts | High (&lt;-0.3): &gt;6.5 pts.</a:t>
+            </a:r>
+          </a:p>
+          <a:p>
+            <a:pPr>
+              <a:defRPr sz="1300" b="1">
+                <a:solidFill>
+                  <a:srgbClr val="06B6D4"/>
+                </a:solidFill>
+              </a:defRPr>
+            </a:pPr>
+            <a:r>
+              <a:t>• Performance Trend (10% W)</a:t>
+            </a:r>
+          </a:p>
+          <a:p>
+            <a:pPr>
+              <a:spcAft>
+                <a:spcPts val="400"/>
+              </a:spcAft>
+              <a:defRPr sz="1000">
+                <a:solidFill>
+                  <a:srgbClr val="F8FAFC"/>
+                </a:solidFill>
+              </a:defRPr>
+            </a:pPr>
+            <a:r>
+              <a:t>Categorical Multiplier: High (0.0), Improving (2.0), Stable (4.5), Declining (8.0), Low (10.0).</a:t>
+            </a:r>
+          </a:p>
+          <a:p>
+            <a:pPr>
+              <a:defRPr sz="1300" b="1">
+                <a:solidFill>
+                  <a:srgbClr val="06B6D4"/>
+                </a:solidFill>
+              </a:defRPr>
+            </a:pPr>
+            <a:r>
+              <a:t>• Compensation Gap (10% W)</a:t>
+            </a:r>
+          </a:p>
+          <a:p>
+            <a:pPr>
+              <a:spcAft>
+                <a:spcPts val="400"/>
+              </a:spcAft>
+              <a:defRPr sz="1000">
+                <a:solidFill>
+                  <a:srgbClr val="F8FAFC"/>
+                </a:solidFill>
+              </a:defRPr>
+            </a:pPr>
+            <a:r>
+              <a:t>Formula: (1 - SalaryPercentile/100) * 10</a:t>
+            </a:r>
+            <a:br/>
+            <a:r>
+              <a:t>- Safe (&gt;60th pct): 0.0 - 4.0 pts | Warning (40-60th pct): 4.0 - 6.0 pts | High (&lt;40th pct): &gt;6.0 pts.</a:t>
+            </a:r>
+          </a:p>
+          <a:p>
+            <a:pPr>
+              <a:defRPr sz="1300" b="1">
+                <a:solidFill>
+                  <a:srgbClr val="06B6D4"/>
+                </a:solidFill>
+              </a:defRPr>
+            </a:pPr>
+            <a:r>
+              <a:t>• Internal Searches (8% W)</a:t>
+            </a:r>
+          </a:p>
+          <a:p>
+            <a:pPr>
+              <a:spcAft>
+                <a:spcPts val="400"/>
+              </a:spcAft>
+              <a:defRPr sz="1000">
+                <a:solidFill>
+                  <a:srgbClr val="F8FAFC"/>
+                </a:solidFill>
+              </a:defRPr>
+            </a:pPr>
+            <a:r>
+              <a:t>Formula: min(Searches/15, 1.0) * 8</a:t>
+            </a:r>
+            <a:br/>
+            <a:r>
+              <a:t>- Safe (0-2): 0.0 - 1.07 pts | Warning (3-5) | High (&gt;5): &gt;2.67 pts.</a:t>
+            </a:r>
+          </a:p>
+          <a:p>
+            <a:pPr>
+              <a:defRPr sz="1300" b="1">
+                <a:solidFill>
+                  <a:srgbClr val="06B6D4"/>
+                </a:solidFill>
+              </a:defRPr>
+            </a:pPr>
+            <a:r>
+              <a:t>• Manager Scorecard (8% W)</a:t>
+            </a:r>
+          </a:p>
+          <a:p>
+            <a:pPr>
+              <a:spcAft>
+                <a:spcPts val="400"/>
+              </a:spcAft>
+              <a:defRPr sz="1000">
+                <a:solidFill>
+                  <a:srgbClr val="F8FAFC"/>
+                </a:solidFill>
+              </a:defRPr>
+            </a:pPr>
+            <a:r>
+              <a:t>Formula: (1 - ManagerScore/10) * 8</a:t>
+            </a:r>
+            <a:br/>
+            <a:r>
+              <a:t>- Safe (&gt;7): 0.0 - 2.4 pts | High (&lt;5): &gt;4.0 pts.</a:t>
+            </a:r>
+          </a:p>
+          <a:p>
+            <a:pPr>
+              <a:defRPr sz="1300" b="1">
+                <a:solidFill>
+                  <a:srgbClr val="06B6D4"/>
+                </a:solidFill>
+              </a:defRPr>
+            </a:pPr>
+            <a:r>
+              <a:t>• Promotion Gap (8% W)</a:t>
+            </a:r>
+          </a:p>
+          <a:p>
+            <a:pPr>
+              <a:spcAft>
+                <a:spcPts val="400"/>
+              </a:spcAft>
+              <a:defRPr sz="1000">
+                <a:solidFill>
+                  <a:srgbClr val="F8FAFC"/>
+                </a:solidFill>
+              </a:defRPr>
+            </a:pPr>
+            <a:r>
+              <a:t>Formula: min(YearsSincePromo/5, 1.0) * 8</a:t>
+            </a:r>
+            <a:br/>
+            <a:r>
+              <a:t>- Safe (&lt;2 yrs): 0.0 - 3.2 pts | High (&gt;3 yrs): &gt;4.8 pts.</a:t>
+            </a:r>
+          </a:p>
+        </p:txBody>
+      </p:sp>
+      <p:sp>
+        <p:nvSpPr>
+          <p:cNvPr id="4" name="TextBox 3"/>
+          <p:cNvSpPr txBox="1"/>
+          <p:nvPr/>
+        </p:nvSpPr>
+        <p:spPr>
+          <a:xfrm>
+            <a:off x="6217920" y="1645920"/>
+            <a:ext cx="5303520" cy="4572000"/>
+          </a:xfrm>
+          <a:prstGeom prst="rect">
+            <a:avLst/>
+          </a:prstGeom>
+          <a:noFill/>
+        </p:spPr>
+        <p:txBody>
+          <a:bodyPr wrap="square">
+            <a:spAutoFit/>
+          </a:bodyPr>
+          <a:lstStyle/>
+          <a:p/>
+          <a:p>
+            <a:pPr>
+              <a:defRPr sz="1300" b="1">
+                <a:solidFill>
+                  <a:srgbClr val="06B6D4"/>
+                </a:solidFill>
+              </a:defRPr>
+            </a:pPr>
+            <a:r>
+              <a:t>• Meeting Attendance (6% W)</a:t>
+            </a:r>
+          </a:p>
+          <a:p>
+            <a:pPr>
+              <a:spcAft>
+                <a:spcPts val="400"/>
+              </a:spcAft>
+              <a:defRPr sz="1000">
+                <a:solidFill>
+                  <a:srgbClr val="F8FAFC"/>
+                </a:solidFill>
+              </a:defRPr>
+            </a:pPr>
+            <a:r>
+              <a:t>Formula: (1 - ParticipationRate) * 6</a:t>
+            </a:r>
+            <a:br/>
+            <a:r>
+              <a:t>- Safe (&gt;70%): 0.0 - 1.8 pts | High (&lt;50%): &gt;3.0 pts.</a:t>
+            </a:r>
+          </a:p>
+          <a:p>
+            <a:pPr>
+              <a:defRPr sz="1300" b="1">
+                <a:solidFill>
+                  <a:srgbClr val="06B6D4"/>
+                </a:solidFill>
+              </a:defRPr>
+            </a:pPr>
+            <a:r>
+              <a:t>• Collaboration Index (6% W)</a:t>
+            </a:r>
+          </a:p>
+          <a:p>
+            <a:pPr>
+              <a:spcAft>
+                <a:spcPts val="400"/>
+              </a:spcAft>
+              <a:defRPr sz="1000">
+                <a:solidFill>
+                  <a:srgbClr val="F8FAFC"/>
+                </a:solidFill>
+              </a:defRPr>
+            </a:pPr>
+            <a:r>
+              <a:t>Formula: (1 - CollabIndex) * 6</a:t>
+            </a:r>
+            <a:br/>
+            <a:r>
+              <a:t>- Safe (&gt;70%): 0.0 - 1.8 pts | High (&lt;40%): &gt;3.6 pts.</a:t>
+            </a:r>
+          </a:p>
+          <a:p>
+            <a:pPr>
+              <a:defRPr sz="1300" b="1">
+                <a:solidFill>
+                  <a:srgbClr val="06B6D4"/>
+                </a:solidFill>
+              </a:defRPr>
+            </a:pPr>
+            <a:r>
+              <a:t>• Training Activity (6% W)</a:t>
+            </a:r>
+          </a:p>
+          <a:p>
+            <a:pPr>
+              <a:spcAft>
+                <a:spcPts val="400"/>
+              </a:spcAft>
+              <a:defRPr sz="1000">
+                <a:solidFill>
+                  <a:srgbClr val="F8FAFC"/>
+                </a:solidFill>
+              </a:defRPr>
+            </a:pPr>
+            <a:r>
+              <a:t>Formula: max(0.0, 1 - TrainingsYTD/8) * 6</a:t>
+            </a:r>
+            <a:br/>
+            <a:r>
+              <a:t>- Safe (&gt;4): 0.0 - 3.0 pts | High (0 in 6m): &gt;4.5 pts.</a:t>
+            </a:r>
+          </a:p>
+          <a:p>
+            <a:pPr>
+              <a:defRPr sz="1300" b="1">
+                <a:solidFill>
+                  <a:srgbClr val="06B6D4"/>
+                </a:solidFill>
+              </a:defRPr>
+            </a:pPr>
+            <a:r>
+              <a:t>• Awards Count (6% W)</a:t>
+            </a:r>
+          </a:p>
+          <a:p>
+            <a:pPr>
+              <a:spcAft>
+                <a:spcPts val="400"/>
+              </a:spcAft>
+              <a:defRPr sz="1000">
+                <a:solidFill>
+                  <a:srgbClr val="F8FAFC"/>
+                </a:solidFill>
+              </a:defRPr>
+            </a:pPr>
+            <a:r>
+              <a:t>Formula: max(0.0, 1 - AwardsCount/5) * 6</a:t>
+            </a:r>
+            <a:br/>
+            <a:r>
+              <a:t>- Safe (&gt;=2): 0.0 - 3.6 pts | High (0 in 12m): 6.0 pts.</a:t>
+            </a:r>
+          </a:p>
+          <a:p>
+            <a:pPr>
+              <a:defRPr sz="1300" b="1">
+                <a:solidFill>
+                  <a:srgbClr val="06B6D4"/>
+                </a:solidFill>
+              </a:defRPr>
+            </a:pPr>
+            <a:r>
+              <a:t>• Location Mismatch (5% W)</a:t>
+            </a:r>
+          </a:p>
+          <a:p>
+            <a:pPr>
+              <a:spcAft>
+                <a:spcPts val="400"/>
+              </a:spcAft>
+              <a:defRPr sz="1000">
+                <a:solidFill>
+                  <a:srgbClr val="F8FAFC"/>
+                </a:solidFill>
+              </a:defRPr>
+            </a:pPr>
+            <a:r>
+              <a:t>Binary: Contributes 5.0 points if relocated fresher base_location_match is False, else 0.0.</a:t>
+            </a:r>
+          </a:p>
+          <a:p>
+            <a:pPr>
+              <a:defRPr sz="1300" b="1">
+                <a:solidFill>
+                  <a:srgbClr val="06B6D4"/>
+                </a:solidFill>
+              </a:defRPr>
+            </a:pPr>
+            <a:r>
+              <a:t>• Cross-Functional Work (3% W)</a:t>
+            </a:r>
+          </a:p>
+          <a:p>
+            <a:pPr>
+              <a:spcAft>
+                <a:spcPts val="400"/>
+              </a:spcAft>
+              <a:defRPr sz="1000">
+                <a:solidFill>
+                  <a:srgbClr val="F8FAFC"/>
+                </a:solidFill>
+              </a:defRPr>
+            </a:pPr>
+            <a:r>
+              <a:t>Binary: Contributes 3.0 points if cross_functional_work is False, else 0.0.</a:t>
+            </a:r>
+          </a:p>
+          <a:p>
+            <a:pPr>
+              <a:defRPr sz="1300" b="1">
+                <a:solidFill>
+                  <a:srgbClr val="06B6D4"/>
+                </a:solidFill>
+              </a:defRPr>
+            </a:pPr>
+            <a:r>
+              <a:t>• Team Outings (2% W)</a:t>
+            </a:r>
+          </a:p>
+          <a:p>
+            <a:pPr>
+              <a:spcAft>
+                <a:spcPts val="400"/>
+              </a:spcAft>
+              <a:defRPr sz="1000">
+                <a:solidFill>
+                  <a:srgbClr val="F8FAFC"/>
+                </a:solidFill>
+              </a:defRPr>
+            </a:pPr>
+            <a:r>
+              <a:t>Formula: max(0.0, 1 - Outings/8) * 2</a:t>
+            </a:r>
+            <a:br/>
+            <a:r>
+              <a:t>- Safe (&gt;=4): 0.0 - 1.0 pts | High (0 outings): 2.0 pts.</a:t>
+            </a:r>
+          </a:p>
+          <a:p>
+            <a:pPr>
+              <a:defRPr sz="1300" b="1">
+                <a:solidFill>
+                  <a:srgbClr val="EF4444"/>
+                </a:solidFill>
+              </a:defRPr>
+            </a:pPr>
+            <a:r>
+              <a:t>• 🔥 Signal #15: Weekly Hours (5% W)</a:t>
+            </a:r>
+          </a:p>
+          <a:p>
+            <a:pPr>
+              <a:spcAft>
+                <a:spcPts val="400"/>
+              </a:spcAft>
+              <a:defRPr sz="1000">
+                <a:solidFill>
+                  <a:srgbClr val="F8FAFC"/>
+                </a:solidFill>
+              </a:defRPr>
+            </a:pPr>
+            <a:r>
+              <a:t>Formula: min(max(0.0, Hours - 40)/20, 1.0) * 5</a:t>
+            </a:r>
+            <a:br/>
+            <a:r>
+              <a:t>- Safe (&lt;44h): 0.0 - 1.0 pts | High (&gt;48h): 2.0 pts | Critical (&gt;55h): &gt;3.7 pts.</a:t>
+            </a:r>
+          </a:p>
+        </p:txBody>
+      </p:sp>
+    </p:spTree>
+  </p:cSld>
+  <p:clrMapOvr>
+    <a:masterClrMapping/>
+  </p:clrMapOvr>
+</p:sld>
+</file>
+
+<file path=ppt/slides/slide6.xml><?xml version="1.0" encoding="utf-8"?>
 <p:sld xmlns:a="http://schemas.openxmlformats.org/drawingml/2006/main" xmlns:p="http://schemas.openxmlformats.org/presentationml/2006/main" xmlns:r="http://schemas.openxmlformats.org/officeDocument/2006/relationships">
   <p:cSld>
     <p:bg>
@@ -4169,657 +5565,6 @@
 </p:sld>
 </file>
 
-<file path=ppt/slides/slide5.xml><?xml version="1.0" encoding="utf-8"?>
-<p:sld xmlns:a="http://schemas.openxmlformats.org/drawingml/2006/main" xmlns:p="http://schemas.openxmlformats.org/presentationml/2006/main" xmlns:r="http://schemas.openxmlformats.org/officeDocument/2006/relationships">
-  <p:cSld>
-    <p:bg>
-      <p:bgPr>
-        <a:solidFill>
-          <a:srgbClr val="0F172A"/>
-        </a:solidFill>
-        <a:effectLst/>
-      </p:bgPr>
-    </p:bg>
-    <p:spTree>
-      <p:nvGrpSpPr>
-        <p:cNvPr id="1" name=""/>
-        <p:cNvGrpSpPr/>
-        <p:nvPr/>
-      </p:nvGrpSpPr>
-      <p:grpSpPr/>
-      <p:sp>
-        <p:nvSpPr>
-          <p:cNvPr id="2" name="TextBox 1"/>
-          <p:cNvSpPr txBox="1"/>
-          <p:nvPr/>
-        </p:nvSpPr>
-        <p:spPr>
-          <a:xfrm>
-            <a:off x="685800" y="365760"/>
-            <a:ext cx="10789920" cy="914400"/>
-          </a:xfrm>
-          <a:prstGeom prst="rect">
-            <a:avLst/>
-          </a:prstGeom>
-          <a:noFill/>
-        </p:spPr>
-        <p:txBody>
-          <a:bodyPr wrap="square">
-            <a:spAutoFit/>
-          </a:bodyPr>
-          <a:lstStyle/>
-          <a:p>
-            <a:pPr>
-              <a:defRPr sz="3200" b="1">
-                <a:solidFill>
-                  <a:srgbClr val="06B6D4"/>
-                </a:solidFill>
-              </a:defRPr>
-            </a:pPr>
-            <a:r>
-              <a:t>Step 2 &amp; 3: Sentiment NLP &amp; Risk Indexing</a:t>
-            </a:r>
-          </a:p>
-          <a:p>
-            <a:pPr>
-              <a:defRPr sz="1600">
-                <a:solidFill>
-                  <a:srgbClr val="F8FAFC"/>
-                </a:solidFill>
-              </a:defRPr>
-            </a:pPr>
-            <a:r>
-              <a:t>Empathetic Text Processing + Categorical Attrition Windows</a:t>
-            </a:r>
-          </a:p>
-        </p:txBody>
-      </p:sp>
-      <p:sp>
-        <p:nvSpPr>
-          <p:cNvPr id="3" name="TextBox 2"/>
-          <p:cNvSpPr txBox="1"/>
-          <p:nvPr/>
-        </p:nvSpPr>
-        <p:spPr>
-          <a:xfrm>
-            <a:off x="685800" y="1645920"/>
-            <a:ext cx="5120640" cy="4572000"/>
-          </a:xfrm>
-          <a:prstGeom prst="rect">
-            <a:avLst/>
-          </a:prstGeom>
-          <a:noFill/>
-        </p:spPr>
-        <p:txBody>
-          <a:bodyPr wrap="square">
-            <a:spAutoFit/>
-          </a:bodyPr>
-          <a:lstStyle/>
-          <a:p/>
-          <a:p>
-            <a:pPr>
-              <a:spcAft>
-                <a:spcPts val="1000"/>
-              </a:spcAft>
-              <a:defRPr sz="2000" b="1">
-                <a:solidFill>
-                  <a:srgbClr val="06B6D4"/>
-                </a:solidFill>
-              </a:defRPr>
-            </a:pPr>
-            <a:r>
-              <a:t>Step 2: Sentiment NLP Processing</a:t>
-            </a:r>
-          </a:p>
-          <a:p>
-            <a:pPr>
-              <a:spcAft>
-                <a:spcPts val="800"/>
-              </a:spcAft>
-              <a:defRPr b="1" sz="1200">
-                <a:solidFill>
-                  <a:srgbClr val="F8FAFC"/>
-                </a:solidFill>
-              </a:defRPr>
-            </a:pPr>
-            <a:r>
-              <a:t>• Real-Time NLP Parsing: </a:t>
-            </a:r>
-            <a:r>
-              <a:t>Evaluates employee written feedback, pulse surveys, and ticket updates.</a:t>
-            </a:r>
-          </a:p>
-          <a:p>
-            <a:pPr>
-              <a:spcAft>
-                <a:spcPts val="800"/>
-              </a:spcAft>
-              <a:defRPr b="1" sz="1200">
-                <a:solidFill>
-                  <a:srgbClr val="F8FAFC"/>
-                </a:solidFill>
-              </a:defRPr>
-            </a:pPr>
-            <a:r>
-              <a:t>• Numeric Mood Indexing: </a:t>
-            </a:r>
-            <a:r>
-              <a:t>Converts qualitative feedback into a scalar range from -1.0 (Highly Disengaged) to +1.0 (Enthusiastic).</a:t>
-            </a:r>
-          </a:p>
-          <a:p>
-            <a:pPr>
-              <a:spcAft>
-                <a:spcPts val="800"/>
-              </a:spcAft>
-              <a:defRPr b="1" sz="1200">
-                <a:solidFill>
-                  <a:srgbClr val="F8FAFC"/>
-                </a:solidFill>
-              </a:defRPr>
-            </a:pPr>
-            <a:r>
-              <a:t>• Core Theme Extraction: </a:t>
-            </a:r>
-            <a:r>
-              <a:t>Identifies specific pain points such as 'burnout', 'career_stagnation', 'workload_pressure', or 'manager_friction'.</a:t>
-            </a:r>
-          </a:p>
-          <a:p>
-            <a:pPr>
-              <a:spcAft>
-                <a:spcPts val="800"/>
-              </a:spcAft>
-              <a:defRPr b="1" sz="1200">
-                <a:solidFill>
-                  <a:srgbClr val="F8FAFC"/>
-                </a:solidFill>
-              </a:defRPr>
-            </a:pPr>
-            <a:r>
-              <a:t>• Contextual Synthesis: </a:t>
-            </a:r>
-            <a:r>
-              <a:t>Enables the Orchestrator to understand the human story behind the numbers.</a:t>
-            </a:r>
-          </a:p>
-        </p:txBody>
-      </p:sp>
-      <p:sp>
-        <p:nvSpPr>
-          <p:cNvPr id="4" name="TextBox 3"/>
-          <p:cNvSpPr txBox="1"/>
-          <p:nvPr/>
-        </p:nvSpPr>
-        <p:spPr>
-          <a:xfrm>
-            <a:off x="6217920" y="1645920"/>
-            <a:ext cx="5303520" cy="4572000"/>
-          </a:xfrm>
-          <a:prstGeom prst="rect">
-            <a:avLst/>
-          </a:prstGeom>
-          <a:noFill/>
-        </p:spPr>
-        <p:txBody>
-          <a:bodyPr wrap="square">
-            <a:spAutoFit/>
-          </a:bodyPr>
-          <a:lstStyle/>
-          <a:p/>
-          <a:p>
-            <a:pPr>
-              <a:spcAft>
-                <a:spcPts val="1000"/>
-              </a:spcAft>
-              <a:defRPr sz="2000" b="1">
-                <a:solidFill>
-                  <a:srgbClr val="06B6D4"/>
-                </a:solidFill>
-              </a:defRPr>
-            </a:pPr>
-            <a:r>
-              <a:t>Step 3: Risk Level Classification</a:t>
-            </a:r>
-          </a:p>
-          <a:p>
-            <a:pPr>
-              <a:defRPr sz="1400" b="1">
-                <a:solidFill>
-                  <a:srgbClr val="EF4444"/>
-                </a:solidFill>
-              </a:defRPr>
-            </a:pPr>
-            <a:r>
-              <a:t>🔴 CRITICAL (Score &gt;= 80%)</a:t>
-            </a:r>
-          </a:p>
-          <a:p>
-            <a:pPr>
-              <a:spcAft>
-                <a:spcPts val="600"/>
-              </a:spcAft>
-              <a:defRPr sz="1100">
-                <a:solidFill>
-                  <a:srgbClr val="F8FAFC"/>
-                </a:solidFill>
-              </a:defRPr>
-            </a:pPr>
-            <a:r>
-              <a:t>Action Window: &lt; 3 months. Requires immediate senior HR intervention and salary/overtime audit.</a:t>
-            </a:r>
-          </a:p>
-          <a:p>
-            <a:pPr>
-              <a:defRPr sz="1400" b="1">
-                <a:solidFill>
-                  <a:srgbClr val="F97316"/>
-                </a:solidFill>
-              </a:defRPr>
-            </a:pPr>
-            <a:r>
-              <a:t>🟠 HIGH (Score 60% - 79%)</a:t>
-            </a:r>
-          </a:p>
-          <a:p>
-            <a:pPr>
-              <a:spcAft>
-                <a:spcPts val="600"/>
-              </a:spcAft>
-              <a:defRPr sz="1100">
-                <a:solidFill>
-                  <a:srgbClr val="F8FAFC"/>
-                </a:solidFill>
-              </a:defRPr>
-            </a:pPr>
-            <a:r>
-              <a:t>Action Window: &lt; 6 months. Triggers automated manager check-ins, skip-levels, and workload cap.</a:t>
-            </a:r>
-          </a:p>
-          <a:p>
-            <a:pPr>
-              <a:defRPr sz="1400" b="1">
-                <a:solidFill>
-                  <a:srgbClr val="F97316"/>
-                </a:solidFill>
-              </a:defRPr>
-            </a:pPr>
-            <a:r>
-              <a:t>🟡 MODERATE (Score 35% - 59%)</a:t>
-            </a:r>
-          </a:p>
-          <a:p>
-            <a:pPr>
-              <a:spcAft>
-                <a:spcPts val="600"/>
-              </a:spcAft>
-              <a:defRPr sz="1100">
-                <a:solidFill>
-                  <a:srgbClr val="F8FAFC"/>
-                </a:solidFill>
-              </a:defRPr>
-            </a:pPr>
-            <a:r>
-              <a:t>Action Window: &lt; 12 months. Requires quarterly reviews, skill alignment, and training incentives.</a:t>
-            </a:r>
-          </a:p>
-          <a:p>
-            <a:pPr>
-              <a:defRPr sz="1400" b="1">
-                <a:solidFill>
-                  <a:srgbClr val="06B6D4"/>
-                </a:solidFill>
-              </a:defRPr>
-            </a:pPr>
-            <a:r>
-              <a:t>🟢 LOW (Score &lt; 35%)</a:t>
-            </a:r>
-          </a:p>
-          <a:p>
-            <a:pPr>
-              <a:spcAft>
-                <a:spcPts val="600"/>
-              </a:spcAft>
-              <a:defRPr sz="1100">
-                <a:solidFill>
-                  <a:srgbClr val="F8FAFC"/>
-                </a:solidFill>
-              </a:defRPr>
-            </a:pPr>
-            <a:r>
-              <a:t>Stable tier. Monitored on a standard bi-annual cycle.</a:t>
-            </a:r>
-          </a:p>
-        </p:txBody>
-      </p:sp>
-    </p:spTree>
-  </p:cSld>
-  <p:clrMapOvr>
-    <a:masterClrMapping/>
-  </p:clrMapOvr>
-</p:sld>
-</file>
-
-<file path=ppt/slides/slide6.xml><?xml version="1.0" encoding="utf-8"?>
-<p:sld xmlns:a="http://schemas.openxmlformats.org/drawingml/2006/main" xmlns:p="http://schemas.openxmlformats.org/presentationml/2006/main" xmlns:r="http://schemas.openxmlformats.org/officeDocument/2006/relationships">
-  <p:cSld>
-    <p:bg>
-      <p:bgPr>
-        <a:solidFill>
-          <a:srgbClr val="0F172A"/>
-        </a:solidFill>
-        <a:effectLst/>
-      </p:bgPr>
-    </p:bg>
-    <p:spTree>
-      <p:nvGrpSpPr>
-        <p:cNvPr id="1" name=""/>
-        <p:cNvGrpSpPr/>
-        <p:nvPr/>
-      </p:nvGrpSpPr>
-      <p:grpSpPr/>
-      <p:sp>
-        <p:nvSpPr>
-          <p:cNvPr id="2" name="TextBox 1"/>
-          <p:cNvSpPr txBox="1"/>
-          <p:nvPr/>
-        </p:nvSpPr>
-        <p:spPr>
-          <a:xfrm>
-            <a:off x="685800" y="365760"/>
-            <a:ext cx="10789920" cy="914400"/>
-          </a:xfrm>
-          <a:prstGeom prst="rect">
-            <a:avLst/>
-          </a:prstGeom>
-          <a:noFill/>
-        </p:spPr>
-        <p:txBody>
-          <a:bodyPr wrap="square">
-            <a:spAutoFit/>
-          </a:bodyPr>
-          <a:lstStyle/>
-          <a:p>
-            <a:pPr>
-              <a:defRPr sz="3200" b="1">
-                <a:solidFill>
-                  <a:srgbClr val="06B6D4"/>
-                </a:solidFill>
-              </a:defRPr>
-            </a:pPr>
-            <a:r>
-              <a:t>Step 4 &amp; 5: Retention Playbooks &amp; Security Safeguards</a:t>
-            </a:r>
-          </a:p>
-          <a:p>
-            <a:pPr>
-              <a:defRPr sz="1600">
-                <a:solidFill>
-                  <a:srgbClr val="F8FAFC"/>
-                </a:solidFill>
-              </a:defRPr>
-            </a:pPr>
-            <a:r>
-              <a:t>Prescriptive Mitigation + Enterprise Privacy and Governance Guardrails</a:t>
-            </a:r>
-          </a:p>
-        </p:txBody>
-      </p:sp>
-      <p:sp>
-        <p:nvSpPr>
-          <p:cNvPr id="3" name="TextBox 2"/>
-          <p:cNvSpPr txBox="1"/>
-          <p:nvPr/>
-        </p:nvSpPr>
-        <p:spPr>
-          <a:xfrm>
-            <a:off x="685800" y="1645920"/>
-            <a:ext cx="5120640" cy="4572000"/>
-          </a:xfrm>
-          <a:prstGeom prst="rect">
-            <a:avLst/>
-          </a:prstGeom>
-          <a:noFill/>
-        </p:spPr>
-        <p:txBody>
-          <a:bodyPr wrap="square">
-            <a:spAutoFit/>
-          </a:bodyPr>
-          <a:lstStyle/>
-          <a:p/>
-          <a:p>
-            <a:pPr>
-              <a:spcAft>
-                <a:spcPts val="1000"/>
-              </a:spcAft>
-              <a:defRPr sz="2000" b="1">
-                <a:solidFill>
-                  <a:srgbClr val="06B6D4"/>
-                </a:solidFill>
-              </a:defRPr>
-            </a:pPr>
-            <a:r>
-              <a:t>Step 4: AI Retention Advisor</a:t>
-            </a:r>
-          </a:p>
-          <a:p>
-            <a:pPr>
-              <a:spcAft>
-                <a:spcPts val="800"/>
-              </a:spcAft>
-              <a:defRPr b="1" sz="1200">
-                <a:solidFill>
-                  <a:srgbClr val="F8FAFC"/>
-                </a:solidFill>
-              </a:defRPr>
-            </a:pPr>
-            <a:r>
-              <a:t>• Overtime &amp; Hours Playbook: </a:t>
-            </a:r>
-            <a:r>
-              <a:t>Mitigates burnout by enforcing strict weekend caps, shifting loads, or introducing flexi-time.</a:t>
-            </a:r>
-          </a:p>
-          <a:p>
-            <a:pPr>
-              <a:spcAft>
-                <a:spcPts val="800"/>
-              </a:spcAft>
-              <a:defRPr b="1" sz="1200">
-                <a:solidFill>
-                  <a:srgbClr val="F8FAFC"/>
-                </a:solidFill>
-              </a:defRPr>
-            </a:pPr>
-            <a:r>
-              <a:t>• Compensation Review Playbook: </a:t>
-            </a:r>
-            <a:r>
-              <a:t>Initiates salary percentile benchmarks vs. market averages and prepares business case for increases.</a:t>
-            </a:r>
-          </a:p>
-          <a:p>
-            <a:pPr>
-              <a:spcAft>
-                <a:spcPts val="800"/>
-              </a:spcAft>
-              <a:defRPr b="1" sz="1200">
-                <a:solidFill>
-                  <a:srgbClr val="F8FAFC"/>
-                </a:solidFill>
-              </a:defRPr>
-            </a:pPr>
-            <a:r>
-              <a:t>• Career Stagnation Playbook: </a:t>
-            </a:r>
-            <a:r>
-              <a:t>Fast-tracks performance appraisals, assigns mentors, and allocates training budgets.</a:t>
-            </a:r>
-          </a:p>
-          <a:p>
-            <a:pPr>
-              <a:spcAft>
-                <a:spcPts val="800"/>
-              </a:spcAft>
-              <a:defRPr b="1" sz="1200">
-                <a:solidFill>
-                  <a:srgbClr val="F8FAFC"/>
-                </a:solidFill>
-              </a:defRPr>
-            </a:pPr>
-            <a:r>
-              <a:t>• Manager Alignment Playbook: </a:t>
-            </a:r>
-            <a:r>
-              <a:t>Initiates skip-level check-ins and offers communication support to the team lead.</a:t>
-            </a:r>
-          </a:p>
-        </p:txBody>
-      </p:sp>
-      <p:sp>
-        <p:nvSpPr>
-          <p:cNvPr id="4" name="TextBox 3"/>
-          <p:cNvSpPr txBox="1"/>
-          <p:nvPr/>
-        </p:nvSpPr>
-        <p:spPr>
-          <a:xfrm>
-            <a:off x="6217920" y="1645920"/>
-            <a:ext cx="5303520" cy="4572000"/>
-          </a:xfrm>
-          <a:prstGeom prst="rect">
-            <a:avLst/>
-          </a:prstGeom>
-          <a:noFill/>
-        </p:spPr>
-        <p:txBody>
-          <a:bodyPr wrap="square">
-            <a:spAutoFit/>
-          </a:bodyPr>
-          <a:lstStyle/>
-          <a:p/>
-          <a:p>
-            <a:pPr>
-              <a:spcAft>
-                <a:spcPts val="1000"/>
-              </a:spcAft>
-              <a:defRPr sz="2000" b="1">
-                <a:solidFill>
-                  <a:srgbClr val="06B6D4"/>
-                </a:solidFill>
-              </a:defRPr>
-            </a:pPr>
-            <a:r>
-              <a:t>Step 5: Security &amp; Privacy Gateways</a:t>
-            </a:r>
-          </a:p>
-          <a:p>
-            <a:pPr>
-              <a:defRPr b="1" sz="1400">
-                <a:solidFill>
-                  <a:srgbClr val="06B6D4"/>
-                </a:solidFill>
-              </a:defRPr>
-            </a:pPr>
-            <a:r>
-              <a:t>• PII Redaction Engine</a:t>
-            </a:r>
-          </a:p>
-          <a:p>
-            <a:pPr>
-              <a:spcAft>
-                <a:spcPts val="800"/>
-              </a:spcAft>
-              <a:defRPr sz="1200">
-                <a:solidFill>
-                  <a:srgbClr val="F8FAFC"/>
-                </a:solidFill>
-              </a:defRPr>
-            </a:pPr>
-            <a:r>
-              <a:t>Automatically strips employee names, emails, phones, and actual salaries before queries reach the LLM.</a:t>
-            </a:r>
-          </a:p>
-          <a:p>
-            <a:pPr>
-              <a:defRPr b="1" sz="1400">
-                <a:solidFill>
-                  <a:srgbClr val="06B6D4"/>
-                </a:solidFill>
-              </a:defRPr>
-            </a:pPr>
-            <a:r>
-              <a:t>• Prompt Injection Guardrail</a:t>
-            </a:r>
-          </a:p>
-          <a:p>
-            <a:pPr>
-              <a:spcAft>
-                <a:spcPts val="800"/>
-              </a:spcAft>
-              <a:defRPr sz="1200">
-                <a:solidFill>
-                  <a:srgbClr val="F8FAFC"/>
-                </a:solidFill>
-              </a:defRPr>
-            </a:pPr>
-            <a:r>
-              <a:t>Intercepts adversarial inputs (e.g. 'ignore instructions') and logs them in a security ledger.</a:t>
-            </a:r>
-          </a:p>
-          <a:p>
-            <a:pPr>
-              <a:defRPr b="1" sz="1400">
-                <a:solidFill>
-                  <a:srgbClr val="06B6D4"/>
-                </a:solidFill>
-              </a:defRPr>
-            </a:pPr>
-            <a:r>
-              <a:t>• Role-Based View Permissions</a:t>
-            </a:r>
-          </a:p>
-          <a:p>
-            <a:pPr>
-              <a:spcAft>
-                <a:spcPts val="800"/>
-              </a:spcAft>
-              <a:defRPr sz="1200">
-                <a:solidFill>
-                  <a:srgbClr val="F8FAFC"/>
-                </a:solidFill>
-              </a:defRPr>
-            </a:pPr>
-            <a:r>
-              <a:t>Enforces distinct boundaries:</a:t>
-            </a:r>
-            <a:br/>
-            <a:r>
-              <a:t>- HR Admin: Complete demographics &amp; core data.</a:t>
-            </a:r>
-            <a:br/>
-            <a:r>
-              <a:t>- Analyst: Behavioral telemetry &amp; sentiment.</a:t>
-            </a:r>
-            <a:br/>
-            <a:r>
-              <a:t>- Manager: Performance feedback &amp; check-ins.</a:t>
-            </a:r>
-            <a:br/>
-            <a:r>
-              <a:t>- Employee: Self-service timeline &amp; own metrics only.</a:t>
-            </a:r>
-          </a:p>
-        </p:txBody>
-      </p:sp>
-    </p:spTree>
-  </p:cSld>
-  <p:clrMapOvr>
-    <a:masterClrMapping/>
-  </p:clrMapOvr>
-</p:sld>
-</file>
-
 <file path=ppt/slides/slide7.xml><?xml version="1.0" encoding="utf-8"?>
 <p:sld xmlns:a="http://schemas.openxmlformats.org/drawingml/2006/main" xmlns:p="http://schemas.openxmlformats.org/presentationml/2006/main" xmlns:r="http://schemas.openxmlformats.org/officeDocument/2006/relationships">
   <p:cSld>
@@ -4868,7 +5613,7 @@
               </a:defRPr>
             </a:pPr>
             <a:r>
-              <a:t>AttriSense AI Product Showcase</a:t>
+              <a:t>Step 2 &amp; 3: Sentiment NLP &amp; Risk Indexing</a:t>
             </a:r>
           </a:p>
           <a:p>
@@ -4880,45 +5625,21 @@
               </a:defRPr>
             </a:pPr>
             <a:r>
-              <a:t>Working UI: Generalized Logins, Employee Cockpits, and Auditable Timelines</a:t>
-            </a:r>
-          </a:p>
-        </p:txBody>
-      </p:sp>
-      <p:pic>
-        <p:nvPicPr>
-          <p:cNvPr id="3" name="Picture 2" descr="dashboard_login_page_1783595805098.png"/>
-          <p:cNvPicPr>
-            <a:picLocks noChangeAspect="1"/>
-          </p:cNvPicPr>
+              <a:t>Empathetic Text Processing + Categorical Attrition Windows</a:t>
+            </a:r>
+          </a:p>
+        </p:txBody>
+      </p:sp>
+      <p:sp>
+        <p:nvSpPr>
+          <p:cNvPr id="3" name="TextBox 2"/>
+          <p:cNvSpPr txBox="1"/>
           <p:nvPr/>
-        </p:nvPicPr>
-        <p:blipFill>
-          <a:blip r:embed="rId2"/>
-          <a:stretch>
-            <a:fillRect/>
-          </a:stretch>
-        </p:blipFill>
+        </p:nvSpPr>
         <p:spPr>
           <a:xfrm>
             <a:off x="685800" y="1645920"/>
-            <a:ext cx="3383280" cy="4114800"/>
-          </a:xfrm>
-          <a:prstGeom prst="rect">
-            <a:avLst/>
-          </a:prstGeom>
-        </p:spPr>
-      </p:pic>
-      <p:sp>
-        <p:nvSpPr>
-          <p:cNvPr id="4" name="TextBox 3"/>
-          <p:cNvSpPr txBox="1"/>
-          <p:nvPr/>
-        </p:nvSpPr>
-        <p:spPr>
-          <a:xfrm>
-            <a:off x="685800" y="5852160"/>
-            <a:ext cx="3383280" cy="731520"/>
+            <a:ext cx="5120640" cy="4572000"/>
           </a:xfrm>
           <a:prstGeom prst="rect">
             <a:avLst/>
@@ -4926,58 +5647,110 @@
           <a:noFill/>
         </p:spPr>
         <p:txBody>
-          <a:bodyPr wrap="none">
+          <a:bodyPr wrap="square">
             <a:spAutoFit/>
           </a:bodyPr>
           <a:lstStyle/>
-          <a:p>
-            <a:pPr algn="ctr">
-              <a:defRPr sz="1100">
-                <a:solidFill>
-                  <a:srgbClr val="F8FAFC"/>
-                </a:solidFill>
-              </a:defRPr>
-            </a:pPr>
-            <a:r>
-              <a:t>1. Role-Generalized Portals &amp; Linked Employee Selection List</a:t>
-            </a:r>
-          </a:p>
-        </p:txBody>
-      </p:sp>
-      <p:pic>
-        <p:nvPicPr>
-          <p:cNvPr id="5" name="Picture 4" descr="analyst_edit_modal_1783597018606.png"/>
-          <p:cNvPicPr>
-            <a:picLocks noChangeAspect="1"/>
-          </p:cNvPicPr>
+          <a:p/>
+          <a:p>
+            <a:pPr>
+              <a:spcAft>
+                <a:spcPts val="1000"/>
+              </a:spcAft>
+              <a:defRPr sz="2000" b="1">
+                <a:solidFill>
+                  <a:srgbClr val="06B6D4"/>
+                </a:solidFill>
+              </a:defRPr>
+            </a:pPr>
+            <a:r>
+              <a:t>Step 2: Sentiment NLP Processing</a:t>
+            </a:r>
+          </a:p>
+          <a:p>
+            <a:pPr>
+              <a:spcAft>
+                <a:spcPts val="800"/>
+              </a:spcAft>
+              <a:defRPr b="1" sz="1200">
+                <a:solidFill>
+                  <a:srgbClr val="F8FAFC"/>
+                </a:solidFill>
+              </a:defRPr>
+            </a:pPr>
+            <a:r>
+              <a:t>• Real-Time NLP Parsing: </a:t>
+            </a:r>
+            <a:r>
+              <a:t>Evaluates employee written feedback, pulse surveys, and ticket updates.</a:t>
+            </a:r>
+          </a:p>
+          <a:p>
+            <a:pPr>
+              <a:spcAft>
+                <a:spcPts val="800"/>
+              </a:spcAft>
+              <a:defRPr b="1" sz="1200">
+                <a:solidFill>
+                  <a:srgbClr val="F8FAFC"/>
+                </a:solidFill>
+              </a:defRPr>
+            </a:pPr>
+            <a:r>
+              <a:t>• Numeric Mood Indexing: </a:t>
+            </a:r>
+            <a:r>
+              <a:t>Converts qualitative feedback into a scalar range from -1.0 (Highly Disengaged) to +1.0 (Enthusiastic).</a:t>
+            </a:r>
+          </a:p>
+          <a:p>
+            <a:pPr>
+              <a:spcAft>
+                <a:spcPts val="800"/>
+              </a:spcAft>
+              <a:defRPr b="1" sz="1200">
+                <a:solidFill>
+                  <a:srgbClr val="F8FAFC"/>
+                </a:solidFill>
+              </a:defRPr>
+            </a:pPr>
+            <a:r>
+              <a:t>• Core Theme Extraction: </a:t>
+            </a:r>
+            <a:r>
+              <a:t>Identifies specific pain points such as 'burnout', 'career_stagnation', 'workload_pressure', or 'manager_friction'.</a:t>
+            </a:r>
+          </a:p>
+          <a:p>
+            <a:pPr>
+              <a:spcAft>
+                <a:spcPts val="800"/>
+              </a:spcAft>
+              <a:defRPr b="1" sz="1200">
+                <a:solidFill>
+                  <a:srgbClr val="F8FAFC"/>
+                </a:solidFill>
+              </a:defRPr>
+            </a:pPr>
+            <a:r>
+              <a:t>• Contextual Synthesis: </a:t>
+            </a:r>
+            <a:r>
+              <a:t>Enables the Orchestrator to understand the human story behind the numbers.</a:t>
+            </a:r>
+          </a:p>
+        </p:txBody>
+      </p:sp>
+      <p:sp>
+        <p:nvSpPr>
+          <p:cNvPr id="4" name="TextBox 3"/>
+          <p:cNvSpPr txBox="1"/>
           <p:nvPr/>
-        </p:nvPicPr>
-        <p:blipFill>
-          <a:blip r:embed="rId3"/>
-          <a:stretch>
-            <a:fillRect/>
-          </a:stretch>
-        </p:blipFill>
+        </p:nvSpPr>
         <p:spPr>
           <a:xfrm>
-            <a:off x="4343400" y="1645920"/>
-            <a:ext cx="3383280" cy="4114800"/>
-          </a:xfrm>
-          <a:prstGeom prst="rect">
-            <a:avLst/>
-          </a:prstGeom>
-        </p:spPr>
-      </p:pic>
-      <p:sp>
-        <p:nvSpPr>
-          <p:cNvPr id="6" name="TextBox 5"/>
-          <p:cNvSpPr txBox="1"/>
-          <p:nvPr/>
-        </p:nvSpPr>
-        <p:spPr>
-          <a:xfrm>
-            <a:off x="4343400" y="5852160"/>
-            <a:ext cx="3383280" cy="731520"/>
+            <a:off x="6217920" y="1645920"/>
+            <a:ext cx="5303520" cy="4572000"/>
           </a:xfrm>
           <a:prstGeom prst="rect">
             <a:avLst/>
@@ -4985,12 +5758,43 @@
           <a:noFill/>
         </p:spPr>
         <p:txBody>
-          <a:bodyPr wrap="none">
+          <a:bodyPr wrap="square">
             <a:spAutoFit/>
           </a:bodyPr>
           <a:lstStyle/>
-          <a:p>
-            <a:pPr algn="ctr">
+          <a:p/>
+          <a:p>
+            <a:pPr>
+              <a:spcAft>
+                <a:spcPts val="1000"/>
+              </a:spcAft>
+              <a:defRPr sz="2000" b="1">
+                <a:solidFill>
+                  <a:srgbClr val="06B6D4"/>
+                </a:solidFill>
+              </a:defRPr>
+            </a:pPr>
+            <a:r>
+              <a:t>Step 3: Risk Level Classification</a:t>
+            </a:r>
+          </a:p>
+          <a:p>
+            <a:pPr>
+              <a:defRPr sz="1400" b="1">
+                <a:solidFill>
+                  <a:srgbClr val="EF4444"/>
+                </a:solidFill>
+              </a:defRPr>
+            </a:pPr>
+            <a:r>
+              <a:t>🔴 CRITICAL (Score &gt;= 80%)</a:t>
+            </a:r>
+          </a:p>
+          <a:p>
+            <a:pPr>
+              <a:spcAft>
+                <a:spcPts val="600"/>
+              </a:spcAft>
               <a:defRPr sz="1100">
                 <a:solidFill>
                   <a:srgbClr val="F8FAFC"/>
@@ -4998,58 +5802,26 @@
               </a:defRPr>
             </a:pPr>
             <a:r>
-              <a:t>2. Role-Aligned Form Permissions (Analyst Modal shown)</a:t>
-            </a:r>
-          </a:p>
-        </p:txBody>
-      </p:sp>
-      <p:pic>
-        <p:nvPicPr>
-          <p:cNvPr id="7" name="Picture 6" descr="manager_intervention_timeline_1783597273743.png"/>
-          <p:cNvPicPr>
-            <a:picLocks noChangeAspect="1"/>
-          </p:cNvPicPr>
-          <p:nvPr/>
-        </p:nvPicPr>
-        <p:blipFill>
-          <a:blip r:embed="rId4"/>
-          <a:stretch>
-            <a:fillRect/>
-          </a:stretch>
-        </p:blipFill>
-        <p:spPr>
-          <a:xfrm>
-            <a:off x="8001000" y="1645920"/>
-            <a:ext cx="3383280" cy="4114800"/>
-          </a:xfrm>
-          <a:prstGeom prst="rect">
-            <a:avLst/>
-          </a:prstGeom>
-        </p:spPr>
-      </p:pic>
-      <p:sp>
-        <p:nvSpPr>
-          <p:cNvPr id="8" name="TextBox 7"/>
-          <p:cNvSpPr txBox="1"/>
-          <p:nvPr/>
-        </p:nvSpPr>
-        <p:spPr>
-          <a:xfrm>
-            <a:off x="8001000" y="5852160"/>
-            <a:ext cx="3383280" cy="731520"/>
-          </a:xfrm>
-          <a:prstGeom prst="rect">
-            <a:avLst/>
-          </a:prstGeom>
-          <a:noFill/>
-        </p:spPr>
-        <p:txBody>
-          <a:bodyPr wrap="none">
-            <a:spAutoFit/>
-          </a:bodyPr>
-          <a:lstStyle/>
-          <a:p>
-            <a:pPr algn="ctr">
+              <a:t>Action Window: &lt; 3 months. Requires immediate senior HR intervention and salary/overtime audit.</a:t>
+            </a:r>
+          </a:p>
+          <a:p>
+            <a:pPr>
+              <a:defRPr sz="1400" b="1">
+                <a:solidFill>
+                  <a:srgbClr val="F97316"/>
+                </a:solidFill>
+              </a:defRPr>
+            </a:pPr>
+            <a:r>
+              <a:t>🟠 HIGH (Score 60% - 79%)</a:t>
+            </a:r>
+          </a:p>
+          <a:p>
+            <a:pPr>
+              <a:spcAft>
+                <a:spcPts val="600"/>
+              </a:spcAft>
               <a:defRPr sz="1100">
                 <a:solidFill>
                   <a:srgbClr val="F8FAFC"/>
@@ -5057,7 +5829,61 @@
               </a:defRPr>
             </a:pPr>
             <a:r>
-              <a:t>3. Employee Profile &amp; Chronological Intervention Timeline</a:t>
+              <a:t>Action Window: &lt; 6 months. Triggers automated manager check-ins, skip-levels, and workload cap.</a:t>
+            </a:r>
+          </a:p>
+          <a:p>
+            <a:pPr>
+              <a:defRPr sz="1400" b="1">
+                <a:solidFill>
+                  <a:srgbClr val="F97316"/>
+                </a:solidFill>
+              </a:defRPr>
+            </a:pPr>
+            <a:r>
+              <a:t>🟡 MODERATE (Score 35% - 59%)</a:t>
+            </a:r>
+          </a:p>
+          <a:p>
+            <a:pPr>
+              <a:spcAft>
+                <a:spcPts val="600"/>
+              </a:spcAft>
+              <a:defRPr sz="1100">
+                <a:solidFill>
+                  <a:srgbClr val="F8FAFC"/>
+                </a:solidFill>
+              </a:defRPr>
+            </a:pPr>
+            <a:r>
+              <a:t>Action Window: &lt; 12 months. Requires quarterly reviews, skill alignment, and training incentives.</a:t>
+            </a:r>
+          </a:p>
+          <a:p>
+            <a:pPr>
+              <a:defRPr sz="1400" b="1">
+                <a:solidFill>
+                  <a:srgbClr val="06B6D4"/>
+                </a:solidFill>
+              </a:defRPr>
+            </a:pPr>
+            <a:r>
+              <a:t>🟢 LOW (Score &lt; 35%)</a:t>
+            </a:r>
+          </a:p>
+          <a:p>
+            <a:pPr>
+              <a:spcAft>
+                <a:spcPts val="600"/>
+              </a:spcAft>
+              <a:defRPr sz="1100">
+                <a:solidFill>
+                  <a:srgbClr val="F8FAFC"/>
+                </a:solidFill>
+              </a:defRPr>
+            </a:pPr>
+            <a:r>
+              <a:t>Stable tier. Monitored on a standard bi-annual cycle.</a:t>
             </a:r>
           </a:p>
         </p:txBody>
@@ -5118,7 +5944,7 @@
               </a:defRPr>
             </a:pPr>
             <a:r>
-              <a:t>Jury Figures, Financial ROI &amp; Future Path</a:t>
+              <a:t>Step 4 &amp; 5: Retention Playbooks &amp; Security Safeguards</a:t>
             </a:r>
           </a:p>
           <a:p>
@@ -5130,7 +5956,7 @@
               </a:defRPr>
             </a:pPr>
             <a:r>
-              <a:t>AttriSense AI: Making the Case to Leadership</a:t>
+              <a:t>Prescriptive Mitigation + Enterprise Privacy and Governance Guardrails</a:t>
             </a:r>
           </a:p>
         </p:txBody>
@@ -5160,19 +5986,34 @@
           <a:p>
             <a:pPr>
               <a:spcAft>
+                <a:spcPts val="1000"/>
+              </a:spcAft>
+              <a:defRPr sz="2000" b="1">
+                <a:solidFill>
+                  <a:srgbClr val="06B6D4"/>
+                </a:solidFill>
+              </a:defRPr>
+            </a:pPr>
+            <a:r>
+              <a:t>Step 4: AI Retention Advisor</a:t>
+            </a:r>
+          </a:p>
+          <a:p>
+            <a:pPr>
+              <a:spcAft>
                 <a:spcPts val="800"/>
               </a:spcAft>
-              <a:defRPr b="1" sz="1100">
-                <a:solidFill>
-                  <a:srgbClr val="F8FAFC"/>
-                </a:solidFill>
-              </a:defRPr>
-            </a:pPr>
-            <a:r>
-              <a:t>• Industry Landscape: </a:t>
-            </a:r>
-            <a:r>
-              <a:t>Global IT attrition averages 15% - 20%. LTTS historical attrition hovers around 13% - 18%. Healthy attrition target is 8% - 12%.</a:t>
+              <a:defRPr b="1" sz="1200">
+                <a:solidFill>
+                  <a:srgbClr val="F8FAFC"/>
+                </a:solidFill>
+              </a:defRPr>
+            </a:pPr>
+            <a:r>
+              <a:t>• Overtime &amp; Hours Playbook: </a:t>
+            </a:r>
+            <a:r>
+              <a:t>Mitigates burnout by enforcing strict weekend caps, shifting loads, or introducing flexi-time.</a:t>
             </a:r>
           </a:p>
           <a:p>
@@ -5180,17 +6021,17 @@
               <a:spcAft>
                 <a:spcPts val="800"/>
               </a:spcAft>
-              <a:defRPr b="1" sz="1100">
-                <a:solidFill>
-                  <a:srgbClr val="F8FAFC"/>
-                </a:solidFill>
-              </a:defRPr>
-            </a:pPr>
-            <a:r>
-              <a:t>• Replacing Employee Cost: </a:t>
-            </a:r>
-            <a:r>
-              <a:t>Recruitment, onboarding, productivity loss, and knowledge transfer costs average $10,000 to $15,000 per person.</a:t>
+              <a:defRPr b="1" sz="1200">
+                <a:solidFill>
+                  <a:srgbClr val="F8FAFC"/>
+                </a:solidFill>
+              </a:defRPr>
+            </a:pPr>
+            <a:r>
+              <a:t>• Compensation Review Playbook: </a:t>
+            </a:r>
+            <a:r>
+              <a:t>Initiates salary percentile benchmarks vs. market averages and prepares business case for increases.</a:t>
             </a:r>
           </a:p>
           <a:p>
@@ -5198,20 +6039,17 @@
               <a:spcAft>
                 <a:spcPts val="800"/>
               </a:spcAft>
-              <a:defRPr b="1" sz="1100">
-                <a:solidFill>
-                  <a:srgbClr val="F8FAFC"/>
-                </a:solidFill>
-              </a:defRPr>
-            </a:pPr>
-            <a:r>
-              <a:t>• LTTS Financial ROI Impact: </a:t>
-            </a:r>
-            <a:r>
-              <a:t>For an LTTS-sized base (~23,000 employees) at 15% attrition:
-- Exits: ~3,450/year costing $34.5M to $51.75M.
-- Retaining just 10% of exiting high-performers translates to annual savings of $3.45M to $5.17M.
-- System run cost: under $12,000/year (300x+ ROI!).</a:t>
+              <a:defRPr b="1" sz="1200">
+                <a:solidFill>
+                  <a:srgbClr val="F8FAFC"/>
+                </a:solidFill>
+              </a:defRPr>
+            </a:pPr>
+            <a:r>
+              <a:t>• Career Stagnation Playbook: </a:t>
+            </a:r>
+            <a:r>
+              <a:t>Fast-tracks performance appraisals, assigns mentors, and allocates training budgets.</a:t>
             </a:r>
           </a:p>
           <a:p>
@@ -5219,17 +6057,17 @@
               <a:spcAft>
                 <a:spcPts val="800"/>
               </a:spcAft>
-              <a:defRPr b="1" sz="1100">
-                <a:solidFill>
-                  <a:srgbClr val="F8FAFC"/>
-                </a:solidFill>
-              </a:defRPr>
-            </a:pPr>
-            <a:r>
-              <a:t>• Model Accuracy: </a:t>
-            </a:r>
-            <a:r>
-              <a:t>Built and calibrated against research achieving up to 95% classification accuracy on attrition patterns.</a:t>
+              <a:defRPr b="1" sz="1200">
+                <a:solidFill>
+                  <a:srgbClr val="F8FAFC"/>
+                </a:solidFill>
+              </a:defRPr>
+            </a:pPr>
+            <a:r>
+              <a:t>• Manager Alignment Playbook: </a:t>
+            </a:r>
+            <a:r>
+              <a:t>Initiates skip-level check-ins and offers communication support to the team lead.</a:t>
             </a:r>
           </a:p>
         </p:txBody>
@@ -5268,7 +6106,7 @@
               </a:defRPr>
             </a:pPr>
             <a:r>
-              <a:t>🔮 Future Steps &amp; Managerial Index</a:t>
+              <a:t>Step 5: Security &amp; Privacy Gateways</a:t>
             </a:r>
           </a:p>
           <a:p>
@@ -5280,7 +6118,7 @@
               </a:defRPr>
             </a:pPr>
             <a:r>
-              <a:t>• Managerial Influence (16th Parameter)</a:t>
+              <a:t>• PII Redaction Engine</a:t>
             </a:r>
           </a:p>
           <a:p>
@@ -5295,7 +6133,7 @@
               </a:defRPr>
             </a:pPr>
             <a:r>
-              <a:t>We plan to feed a new signal measuring a manager's history: standard deviation of attrition rates in their team, average team mood ratings, and historical scorecards.</a:t>
+              <a:t>Automatically strips employee names, emails, phones, and actual salaries before queries reach the LLM.</a:t>
             </a:r>
           </a:p>
           <a:p>
@@ -5307,7 +6145,7 @@
               </a:defRPr>
             </a:pPr>
             <a:r>
-              <a:t>• Automatic Coaching &amp; Training</a:t>
+              <a:t>• Prompt Injection Guardrail</a:t>
             </a:r>
           </a:p>
           <a:p>
@@ -5322,7 +6160,7 @@
               </a:defRPr>
             </a:pPr>
             <a:r>
-              <a:t>If a manager's team shows elevated risk flags, the system proactively triggers an internal 'Leadership Development &amp; Management Coaching' program, supporting the manager with skill development rather than penalizing them.</a:t>
+              <a:t>Intercepts adversarial inputs (e.g. 'ignore instructions') and logs them in a security ledger.</a:t>
             </a:r>
           </a:p>
           <a:p>
@@ -5334,7 +6172,7 @@
               </a:defRPr>
             </a:pPr>
             <a:r>
-              <a:t>• Integrations with Corporate HRMS</a:t>
+              <a:t>• Role-Based View Permissions</a:t>
             </a:r>
           </a:p>
           <a:p>
@@ -5349,11 +6187,589 @@
               </a:defRPr>
             </a:pPr>
             <a:r>
-              <a:t>Connect MCP server natively to Workday, SAP SuccessFactors, and local IT logs (Jira, Git, active hours telemetry) for fully automated, continuous prediction.</a:t>
-            </a:r>
-          </a:p>
-        </p:txBody>
-      </p:sp>
+              <a:t>Enforces distinct boundaries:</a:t>
+            </a:r>
+            <a:br/>
+            <a:r>
+              <a:t>- HR Admin: Complete demographics &amp; core data.</a:t>
+            </a:r>
+            <a:br/>
+            <a:r>
+              <a:t>- Analyst: Behavioral telemetry &amp; sentiment.</a:t>
+            </a:r>
+            <a:br/>
+            <a:r>
+              <a:t>- Manager: Performance feedback &amp; check-ins.</a:t>
+            </a:r>
+            <a:br/>
+            <a:r>
+              <a:t>- Employee: Self-service timeline &amp; own metrics only.</a:t>
+            </a:r>
+          </a:p>
+        </p:txBody>
+      </p:sp>
+    </p:spTree>
+  </p:cSld>
+  <p:clrMapOvr>
+    <a:masterClrMapping/>
+  </p:clrMapOvr>
+</p:sld>
+</file>
+
+<file path=ppt/slides/slide9.xml><?xml version="1.0" encoding="utf-8"?>
+<p:sld xmlns:a="http://schemas.openxmlformats.org/drawingml/2006/main" xmlns:p="http://schemas.openxmlformats.org/presentationml/2006/main" xmlns:r="http://schemas.openxmlformats.org/officeDocument/2006/relationships">
+  <p:cSld>
+    <p:bg>
+      <p:bgPr>
+        <a:solidFill>
+          <a:srgbClr val="0F172A"/>
+        </a:solidFill>
+        <a:effectLst/>
+      </p:bgPr>
+    </p:bg>
+    <p:spTree>
+      <p:nvGrpSpPr>
+        <p:cNvPr id="1" name=""/>
+        <p:cNvGrpSpPr/>
+        <p:nvPr/>
+      </p:nvGrpSpPr>
+      <p:grpSpPr/>
+      <p:sp>
+        <p:nvSpPr>
+          <p:cNvPr id="2" name="TextBox 1"/>
+          <p:cNvSpPr txBox="1"/>
+          <p:nvPr/>
+        </p:nvSpPr>
+        <p:spPr>
+          <a:xfrm>
+            <a:off x="685800" y="365760"/>
+            <a:ext cx="10789920" cy="914400"/>
+          </a:xfrm>
+          <a:prstGeom prst="rect">
+            <a:avLst/>
+          </a:prstGeom>
+          <a:noFill/>
+        </p:spPr>
+        <p:txBody>
+          <a:bodyPr wrap="square">
+            <a:spAutoFit/>
+          </a:bodyPr>
+          <a:lstStyle/>
+          <a:p>
+            <a:pPr>
+              <a:defRPr sz="3200" b="1">
+                <a:solidFill>
+                  <a:srgbClr val="06B6D4"/>
+                </a:solidFill>
+              </a:defRPr>
+            </a:pPr>
+            <a:r>
+              <a:t>Competitive Differentiator — Actionable Playbook Execution</a:t>
+            </a:r>
+          </a:p>
+          <a:p>
+            <a:pPr>
+              <a:defRPr sz="1600">
+                <a:solidFill>
+                  <a:srgbClr val="F8FAFC"/>
+                </a:solidFill>
+              </a:defRPr>
+            </a:pPr>
+            <a:r>
+              <a:t>AttriSense AI vs. Legacy Competitors (Workday, SAP SuccessFactors, and Visier)</a:t>
+            </a:r>
+          </a:p>
+        </p:txBody>
+      </p:sp>
+      <p:sp>
+        <p:nvSpPr>
+          <p:cNvPr id="3" name="TextBox 2"/>
+          <p:cNvSpPr txBox="1"/>
+          <p:nvPr/>
+        </p:nvSpPr>
+        <p:spPr>
+          <a:xfrm>
+            <a:off x="685800" y="1645920"/>
+            <a:ext cx="5120640" cy="4572000"/>
+          </a:xfrm>
+          <a:prstGeom prst="rect">
+            <a:avLst/>
+          </a:prstGeom>
+          <a:noFill/>
+        </p:spPr>
+        <p:txBody>
+          <a:bodyPr wrap="square">
+            <a:spAutoFit/>
+          </a:bodyPr>
+          <a:lstStyle/>
+          <a:p/>
+          <a:p>
+            <a:pPr>
+              <a:spcAft>
+                <a:spcPts val="800"/>
+              </a:spcAft>
+              <a:defRPr b="1" sz="1100">
+                <a:solidFill>
+                  <a:srgbClr val="F8FAFC"/>
+                </a:solidFill>
+              </a:defRPr>
+            </a:pPr>
+            <a:r>
+              <a:t>• Beyond the Risk Score: </a:t>
+            </a:r>
+            <a:r>
+              <a:t>Legacy tools output a raw percentage (e.g. '74% risk') and stop. AttriSense goes further by analyzing the root cause and prescribing step-by-step retention guides.</a:t>
+            </a:r>
+          </a:p>
+          <a:p>
+            <a:pPr>
+              <a:spcAft>
+                <a:spcPts val="800"/>
+              </a:spcAft>
+              <a:defRPr b="1" sz="1100">
+                <a:solidFill>
+                  <a:srgbClr val="F8FAFC"/>
+                </a:solidFill>
+              </a:defRPr>
+            </a:pPr>
+            <a:r>
+              <a:t>• Granular Explainability: </a:t>
+            </a:r>
+            <a:r>
+              <a:t>We display the exact 15-parameter telemetry breakdowns so managers can verify *why* the employee is flagged.</a:t>
+            </a:r>
+          </a:p>
+          <a:p>
+            <a:pPr>
+              <a:spcAft>
+                <a:spcPts val="800"/>
+              </a:spcAft>
+              <a:defRPr b="1" sz="1100">
+                <a:solidFill>
+                  <a:srgbClr val="F8FAFC"/>
+                </a:solidFill>
+              </a:defRPr>
+            </a:pPr>
+            <a:r>
+              <a:t>• Multi-Agent ADK Power: </a:t>
+            </a:r>
+            <a:r>
+              <a:t>Uses a division of labor (Signal, Sentiment, Scoring, Playbooks) to execute reasoning plans in isolation, ensuring safety and precision.</a:t>
+            </a:r>
+          </a:p>
+          <a:p>
+            <a:pPr>
+              <a:spcAft>
+                <a:spcPts val="800"/>
+              </a:spcAft>
+              <a:defRPr b="1" sz="1100">
+                <a:solidFill>
+                  <a:srgbClr val="F8FAFC"/>
+                </a:solidFill>
+              </a:defRPr>
+            </a:pPr>
+            <a:r>
+              <a:t>• MCP Data Connector: </a:t>
+            </a:r>
+            <a:r>
+              <a:t>No invasive multi-month enterprise setup. Model Context Protocol enables connection to existing HR databases in days.</a:t>
+            </a:r>
+          </a:p>
+        </p:txBody>
+      </p:sp>
+      <p:graphicFrame>
+        <p:nvGraphicFramePr>
+          <p:cNvPr id="4" name="Table 3"/>
+          <p:cNvGraphicFramePr>
+            <a:graphicFrameLocks noGrp="1"/>
+          </p:cNvGraphicFramePr>
+          <p:nvPr/>
+        </p:nvGraphicFramePr>
+        <p:xfrm>
+          <a:off x="6217920" y="1645920"/>
+          <a:ext cx="5303520" cy="4114800"/>
+        </p:xfrm>
+        <a:graphic>
+          <a:graphicData uri="http://schemas.openxmlformats.org/drawingml/2006/table">
+            <a:tbl>
+              <a:tblPr firstRow="1" bandRow="1">
+                <a:tableStyleId>{5C22544A-7EE6-4342-B048-85BDC9FD1C3A}</a:tableStyleId>
+              </a:tblPr>
+              <a:tblGrid>
+                <a:gridCol w="2011680"/>
+                <a:gridCol w="1645920"/>
+                <a:gridCol w="1645920"/>
+              </a:tblGrid>
+              <a:tr h="685800">
+                <a:tc>
+                  <a:txBody>
+                    <a:bodyPr/>
+                    <a:lstStyle/>
+                    <a:p>
+                      <a:pPr>
+                        <a:defRPr b="1" sz="1200">
+                          <a:solidFill>
+                            <a:srgbClr val="0F172A"/>
+                          </a:solidFill>
+                        </a:defRPr>
+                      </a:pPr>
+                      <a:r>
+                        <a:t>Feature</a:t>
+                      </a:r>
+                    </a:p>
+                  </a:txBody>
+                  <a:tcPr>
+                    <a:solidFill>
+                      <a:srgbClr val="06B6D4"/>
+                    </a:solidFill>
+                  </a:tcPr>
+                </a:tc>
+                <a:tc>
+                  <a:txBody>
+                    <a:bodyPr/>
+                    <a:lstStyle/>
+                    <a:p>
+                      <a:pPr>
+                        <a:defRPr b="1" sz="1200">
+                          <a:solidFill>
+                            <a:srgbClr val="0F172A"/>
+                          </a:solidFill>
+                        </a:defRPr>
+                      </a:pPr>
+                      <a:r>
+                        <a:t>AttriSense AI</a:t>
+                      </a:r>
+                    </a:p>
+                  </a:txBody>
+                  <a:tcPr>
+                    <a:solidFill>
+                      <a:srgbClr val="06B6D4"/>
+                    </a:solidFill>
+                  </a:tcPr>
+                </a:tc>
+                <a:tc>
+                  <a:txBody>
+                    <a:bodyPr/>
+                    <a:lstStyle/>
+                    <a:p>
+                      <a:pPr>
+                        <a:defRPr b="1" sz="1200">
+                          <a:solidFill>
+                            <a:srgbClr val="0F172A"/>
+                          </a:solidFill>
+                        </a:defRPr>
+                      </a:pPr>
+                      <a:r>
+                        <a:t>Legacy Systems</a:t>
+                      </a:r>
+                    </a:p>
+                  </a:txBody>
+                  <a:tcPr>
+                    <a:solidFill>
+                      <a:srgbClr val="06B6D4"/>
+                    </a:solidFill>
+                  </a:tcPr>
+                </a:tc>
+              </a:tr>
+              <a:tr h="685800">
+                <a:tc>
+                  <a:txBody>
+                    <a:bodyPr/>
+                    <a:lstStyle/>
+                    <a:p>
+                      <a:pPr>
+                        <a:defRPr sz="1100">
+                          <a:solidFill>
+                            <a:srgbClr val="F8FAFC"/>
+                          </a:solidFill>
+                        </a:defRPr>
+                      </a:pPr>
+                      <a:r>
+                        <a:t>Flight Risk score</a:t>
+                      </a:r>
+                    </a:p>
+                  </a:txBody>
+                  <a:tcPr/>
+                </a:tc>
+                <a:tc>
+                  <a:txBody>
+                    <a:bodyPr/>
+                    <a:lstStyle/>
+                    <a:p>
+                      <a:pPr>
+                        <a:defRPr sz="1100" b="1">
+                          <a:solidFill>
+                            <a:srgbClr val="06B6D4"/>
+                          </a:solidFill>
+                        </a:defRPr>
+                      </a:pPr>
+                      <a:r>
+                        <a:t>Yes</a:t>
+                      </a:r>
+                    </a:p>
+                  </a:txBody>
+                  <a:tcPr/>
+                </a:tc>
+                <a:tc>
+                  <a:txBody>
+                    <a:bodyPr/>
+                    <a:lstStyle/>
+                    <a:p>
+                      <a:pPr>
+                        <a:defRPr sz="1100">
+                          <a:solidFill>
+                            <a:srgbClr val="F8FAFC"/>
+                          </a:solidFill>
+                        </a:defRPr>
+                      </a:pPr>
+                      <a:r>
+                        <a:t>Yes</a:t>
+                      </a:r>
+                    </a:p>
+                  </a:txBody>
+                  <a:tcPr/>
+                </a:tc>
+              </a:tr>
+              <a:tr h="685800">
+                <a:tc>
+                  <a:txBody>
+                    <a:bodyPr/>
+                    <a:lstStyle/>
+                    <a:p>
+                      <a:pPr>
+                        <a:defRPr sz="1100">
+                          <a:solidFill>
+                            <a:srgbClr val="F8FAFC"/>
+                          </a:solidFill>
+                        </a:defRPr>
+                      </a:pPr>
+                      <a:r>
+                        <a:t>Root Cause (Why)</a:t>
+                      </a:r>
+                    </a:p>
+                  </a:txBody>
+                  <a:tcPr/>
+                </a:tc>
+                <a:tc>
+                  <a:txBody>
+                    <a:bodyPr/>
+                    <a:lstStyle/>
+                    <a:p>
+                      <a:pPr>
+                        <a:defRPr sz="1100" b="1">
+                          <a:solidFill>
+                            <a:srgbClr val="06B6D4"/>
+                          </a:solidFill>
+                        </a:defRPr>
+                      </a:pPr>
+                      <a:r>
+                        <a:t>Yes (15 parameters)</a:t>
+                      </a:r>
+                    </a:p>
+                  </a:txBody>
+                  <a:tcPr/>
+                </a:tc>
+                <a:tc>
+                  <a:txBody>
+                    <a:bodyPr/>
+                    <a:lstStyle/>
+                    <a:p>
+                      <a:pPr>
+                        <a:defRPr sz="1100">
+                          <a:solidFill>
+                            <a:srgbClr val="F8FAFC"/>
+                          </a:solidFill>
+                        </a:defRPr>
+                      </a:pPr>
+                      <a:r>
+                        <a:t>No (Black Box)</a:t>
+                      </a:r>
+                    </a:p>
+                  </a:txBody>
+                  <a:tcPr/>
+                </a:tc>
+              </a:tr>
+              <a:tr h="685800">
+                <a:tc>
+                  <a:txBody>
+                    <a:bodyPr/>
+                    <a:lstStyle/>
+                    <a:p>
+                      <a:pPr>
+                        <a:defRPr sz="1100">
+                          <a:solidFill>
+                            <a:srgbClr val="F8FAFC"/>
+                          </a:solidFill>
+                        </a:defRPr>
+                      </a:pPr>
+                      <a:r>
+                        <a:t>Personalized Plans</a:t>
+                      </a:r>
+                    </a:p>
+                  </a:txBody>
+                  <a:tcPr/>
+                </a:tc>
+                <a:tc>
+                  <a:txBody>
+                    <a:bodyPr/>
+                    <a:lstStyle/>
+                    <a:p>
+                      <a:pPr>
+                        <a:defRPr sz="1100" b="1">
+                          <a:solidFill>
+                            <a:srgbClr val="06B6D4"/>
+                          </a:solidFill>
+                        </a:defRPr>
+                      </a:pPr>
+                      <a:r>
+                        <a:t>Yes (AI generated)</a:t>
+                      </a:r>
+                    </a:p>
+                  </a:txBody>
+                  <a:tcPr/>
+                </a:tc>
+                <a:tc>
+                  <a:txBody>
+                    <a:bodyPr/>
+                    <a:lstStyle/>
+                    <a:p>
+                      <a:pPr>
+                        <a:defRPr sz="1100">
+                          <a:solidFill>
+                            <a:srgbClr val="F8FAFC"/>
+                          </a:solidFill>
+                        </a:defRPr>
+                      </a:pPr>
+                      <a:r>
+                        <a:t>No (Generic advice)</a:t>
+                      </a:r>
+                    </a:p>
+                  </a:txBody>
+                  <a:tcPr/>
+                </a:tc>
+              </a:tr>
+              <a:tr h="685800">
+                <a:tc>
+                  <a:txBody>
+                    <a:bodyPr/>
+                    <a:lstStyle/>
+                    <a:p>
+                      <a:pPr>
+                        <a:defRPr sz="1100">
+                          <a:solidFill>
+                            <a:srgbClr val="F8FAFC"/>
+                          </a:solidFill>
+                        </a:defRPr>
+                      </a:pPr>
+                      <a:r>
+                        <a:t>PII Redaction Gate</a:t>
+                      </a:r>
+                    </a:p>
+                  </a:txBody>
+                  <a:tcPr/>
+                </a:tc>
+                <a:tc>
+                  <a:txBody>
+                    <a:bodyPr/>
+                    <a:lstStyle/>
+                    <a:p>
+                      <a:pPr>
+                        <a:defRPr sz="1100" b="1">
+                          <a:solidFill>
+                            <a:srgbClr val="06B6D4"/>
+                          </a:solidFill>
+                        </a:defRPr>
+                      </a:pPr>
+                      <a:r>
+                        <a:t>Yes (Local)</a:t>
+                      </a:r>
+                    </a:p>
+                  </a:txBody>
+                  <a:tcPr/>
+                </a:tc>
+                <a:tc>
+                  <a:txBody>
+                    <a:bodyPr/>
+                    <a:lstStyle/>
+                    <a:p>
+                      <a:pPr>
+                        <a:defRPr sz="1100">
+                          <a:solidFill>
+                            <a:srgbClr val="F8FAFC"/>
+                          </a:solidFill>
+                        </a:defRPr>
+                      </a:pPr>
+                      <a:r>
+                        <a:t>No (Requires cloud)</a:t>
+                      </a:r>
+                    </a:p>
+                  </a:txBody>
+                  <a:tcPr/>
+                </a:tc>
+              </a:tr>
+              <a:tr h="685800">
+                <a:tc>
+                  <a:txBody>
+                    <a:bodyPr/>
+                    <a:lstStyle/>
+                    <a:p>
+                      <a:pPr>
+                        <a:defRPr sz="1100">
+                          <a:solidFill>
+                            <a:srgbClr val="F8FAFC"/>
+                          </a:solidFill>
+                        </a:defRPr>
+                      </a:pPr>
+                      <a:r>
+                        <a:t>Deploy Timeline</a:t>
+                      </a:r>
+                    </a:p>
+                  </a:txBody>
+                  <a:tcPr/>
+                </a:tc>
+                <a:tc>
+                  <a:txBody>
+                    <a:bodyPr/>
+                    <a:lstStyle/>
+                    <a:p>
+                      <a:pPr>
+                        <a:defRPr sz="1100" b="1">
+                          <a:solidFill>
+                            <a:srgbClr val="06B6D4"/>
+                          </a:solidFill>
+                        </a:defRPr>
+                      </a:pPr>
+                      <a:r>
+                        <a:t>Days (via MCP)</a:t>
+                      </a:r>
+                    </a:p>
+                  </a:txBody>
+                  <a:tcPr/>
+                </a:tc>
+                <a:tc>
+                  <a:txBody>
+                    <a:bodyPr/>
+                    <a:lstStyle/>
+                    <a:p>
+                      <a:pPr>
+                        <a:defRPr sz="1100">
+                          <a:solidFill>
+                            <a:srgbClr val="F8FAFC"/>
+                          </a:solidFill>
+                        </a:defRPr>
+                      </a:pPr>
+                      <a:r>
+                        <a:t>Months (ERP Suite)</a:t>
+                      </a:r>
+                    </a:p>
+                  </a:txBody>
+                  <a:tcPr/>
+                </a:tc>
+              </a:tr>
+            </a:tbl>
+          </a:graphicData>
+        </a:graphic>
+      </p:graphicFrame>
     </p:spTree>
   </p:cSld>
   <p:clrMapOvr>

</xml_diff>

<commit_message>
docs: update Slide 8 role permissions to align with restructuring
</commit_message>
<xml_diff>
--- a/AttriSense AI — Predictive Attrition Intelligence Platform_3.pptx
+++ b/AttriSense AI — Predictive Attrition Intelligence Platform_3.pptx
@@ -6191,19 +6191,15 @@
             </a:r>
             <a:br/>
             <a:r>
-              <a:t>- HR Admin: Complete demographics &amp; core data.</a:t>
+              <a:t>- Line Manager: Full write/edit access to all 15 parameters, dashboard register, and AI advisor reporting.</a:t>
             </a:r>
             <a:br/>
             <a:r>
-              <a:t>- Analyst: Behavioral telemetry &amp; sentiment.</a:t>
+              <a:t>- HR Team: Read-only access, alert/notification timeline center, and playbook sharing advisor.</a:t>
             </a:r>
             <a:br/>
             <a:r>
-              <a:t>- Manager: Performance feedback &amp; check-ins.</a:t>
-            </a:r>
-            <a:br/>
-            <a:r>
-              <a:t>- Employee: Self-service timeline &amp; own metrics only.</a:t>
+              <a:t>- Security Gate: Analyst &amp; Employee portals disabled to enforce strict data governance.</a:t>
             </a:r>
           </a:p>
         </p:txBody>

</xml_diff>